<commit_message>
cleaning and not doing diff in loop:
</commit_message>
<xml_diff>
--- a/dkw-po-presentation.pptx
+++ b/dkw-po-presentation.pptx
@@ -5,10 +5,10 @@
     <p:sldMasterId id="2147483648" r:id="rId1"/>
   </p:sldMasterIdLst>
   <p:notesMasterIdLst>
-    <p:notesMasterId r:id="rId15"/>
+    <p:notesMasterId r:id="rId22"/>
   </p:notesMasterIdLst>
   <p:handoutMasterIdLst>
-    <p:handoutMasterId r:id="rId16"/>
+    <p:handoutMasterId r:id="rId23"/>
   </p:handoutMasterIdLst>
   <p:sldIdLst>
     <p:sldId id="256" r:id="rId2"/>
@@ -24,6 +24,13 @@
     <p:sldId id="263" r:id="rId12"/>
     <p:sldId id="269" r:id="rId13"/>
     <p:sldId id="270" r:id="rId14"/>
+    <p:sldId id="271" r:id="rId15"/>
+    <p:sldId id="272" r:id="rId16"/>
+    <p:sldId id="277" r:id="rId17"/>
+    <p:sldId id="273" r:id="rId18"/>
+    <p:sldId id="274" r:id="rId19"/>
+    <p:sldId id="276" r:id="rId20"/>
+    <p:sldId id="275" r:id="rId21"/>
   </p:sldIdLst>
   <p:sldSz cx="12192000" cy="6858000"/>
   <p:notesSz cx="6858000" cy="9144000"/>
@@ -6418,6 +6425,2734 @@
   <p:clrMapOvr>
     <a:masterClrMapping/>
   </p:clrMapOvr>
+  <p:timing>
+    <p:tnLst>
+      <p:par>
+        <p:cTn id="1" dur="indefinite" restart="never" nodeType="tmRoot">
+          <p:childTnLst>
+            <p:seq concurrent="1" nextAc="seek">
+              <p:cTn id="2" dur="indefinite" nodeType="mainSeq">
+                <p:childTnLst>
+                  <p:par>
+                    <p:cTn id="3" fill="hold">
+                      <p:stCondLst>
+                        <p:cond delay="indefinite"/>
+                      </p:stCondLst>
+                      <p:childTnLst>
+                        <p:par>
+                          <p:cTn id="4" fill="hold">
+                            <p:stCondLst>
+                              <p:cond delay="0"/>
+                            </p:stCondLst>
+                            <p:childTnLst>
+                              <p:par>
+                                <p:cTn id="5" presetID="1" presetClass="entr" presetSubtype="0" fill="hold" nodeType="clickEffect">
+                                  <p:stCondLst>
+                                    <p:cond delay="0"/>
+                                  </p:stCondLst>
+                                  <p:childTnLst>
+                                    <p:set>
+                                      <p:cBhvr>
+                                        <p:cTn id="6" dur="1" fill="hold">
+                                          <p:stCondLst>
+                                            <p:cond delay="0"/>
+                                          </p:stCondLst>
+                                        </p:cTn>
+                                        <p:tgtEl>
+                                          <p:spTgt spid="3">
+                                            <p:txEl>
+                                              <p:pRg st="0" end="0"/>
+                                            </p:txEl>
+                                          </p:spTgt>
+                                        </p:tgtEl>
+                                        <p:attrNameLst>
+                                          <p:attrName>style.visibility</p:attrName>
+                                        </p:attrNameLst>
+                                      </p:cBhvr>
+                                      <p:to>
+                                        <p:strVal val="visible"/>
+                                      </p:to>
+                                    </p:set>
+                                  </p:childTnLst>
+                                </p:cTn>
+                              </p:par>
+                            </p:childTnLst>
+                          </p:cTn>
+                        </p:par>
+                      </p:childTnLst>
+                    </p:cTn>
+                  </p:par>
+                  <p:par>
+                    <p:cTn id="7" fill="hold">
+                      <p:stCondLst>
+                        <p:cond delay="indefinite"/>
+                      </p:stCondLst>
+                      <p:childTnLst>
+                        <p:par>
+                          <p:cTn id="8" fill="hold">
+                            <p:stCondLst>
+                              <p:cond delay="0"/>
+                            </p:stCondLst>
+                            <p:childTnLst>
+                              <p:par>
+                                <p:cTn id="9" presetID="1" presetClass="entr" presetSubtype="0" fill="hold" nodeType="clickEffect">
+                                  <p:stCondLst>
+                                    <p:cond delay="0"/>
+                                  </p:stCondLst>
+                                  <p:childTnLst>
+                                    <p:set>
+                                      <p:cBhvr>
+                                        <p:cTn id="10" dur="1" fill="hold">
+                                          <p:stCondLst>
+                                            <p:cond delay="0"/>
+                                          </p:stCondLst>
+                                        </p:cTn>
+                                        <p:tgtEl>
+                                          <p:spTgt spid="3">
+                                            <p:txEl>
+                                              <p:pRg st="1" end="1"/>
+                                            </p:txEl>
+                                          </p:spTgt>
+                                        </p:tgtEl>
+                                        <p:attrNameLst>
+                                          <p:attrName>style.visibility</p:attrName>
+                                        </p:attrNameLst>
+                                      </p:cBhvr>
+                                      <p:to>
+                                        <p:strVal val="visible"/>
+                                      </p:to>
+                                    </p:set>
+                                  </p:childTnLst>
+                                </p:cTn>
+                              </p:par>
+                            </p:childTnLst>
+                          </p:cTn>
+                        </p:par>
+                      </p:childTnLst>
+                    </p:cTn>
+                  </p:par>
+                  <p:par>
+                    <p:cTn id="11" fill="hold">
+                      <p:stCondLst>
+                        <p:cond delay="indefinite"/>
+                      </p:stCondLst>
+                      <p:childTnLst>
+                        <p:par>
+                          <p:cTn id="12" fill="hold">
+                            <p:stCondLst>
+                              <p:cond delay="0"/>
+                            </p:stCondLst>
+                            <p:childTnLst>
+                              <p:par>
+                                <p:cTn id="13" presetID="1" presetClass="entr" presetSubtype="0" fill="hold" nodeType="clickEffect">
+                                  <p:stCondLst>
+                                    <p:cond delay="0"/>
+                                  </p:stCondLst>
+                                  <p:childTnLst>
+                                    <p:set>
+                                      <p:cBhvr>
+                                        <p:cTn id="14" dur="1" fill="hold">
+                                          <p:stCondLst>
+                                            <p:cond delay="0"/>
+                                          </p:stCondLst>
+                                        </p:cTn>
+                                        <p:tgtEl>
+                                          <p:spTgt spid="3">
+                                            <p:txEl>
+                                              <p:pRg st="2" end="2"/>
+                                            </p:txEl>
+                                          </p:spTgt>
+                                        </p:tgtEl>
+                                        <p:attrNameLst>
+                                          <p:attrName>style.visibility</p:attrName>
+                                        </p:attrNameLst>
+                                      </p:cBhvr>
+                                      <p:to>
+                                        <p:strVal val="visible"/>
+                                      </p:to>
+                                    </p:set>
+                                  </p:childTnLst>
+                                </p:cTn>
+                              </p:par>
+                            </p:childTnLst>
+                          </p:cTn>
+                        </p:par>
+                      </p:childTnLst>
+                    </p:cTn>
+                  </p:par>
+                  <p:par>
+                    <p:cTn id="15" fill="hold">
+                      <p:stCondLst>
+                        <p:cond delay="indefinite"/>
+                      </p:stCondLst>
+                      <p:childTnLst>
+                        <p:par>
+                          <p:cTn id="16" fill="hold">
+                            <p:stCondLst>
+                              <p:cond delay="0"/>
+                            </p:stCondLst>
+                            <p:childTnLst>
+                              <p:par>
+                                <p:cTn id="17" presetID="1" presetClass="entr" presetSubtype="0" fill="hold" nodeType="clickEffect">
+                                  <p:stCondLst>
+                                    <p:cond delay="0"/>
+                                  </p:stCondLst>
+                                  <p:childTnLst>
+                                    <p:set>
+                                      <p:cBhvr>
+                                        <p:cTn id="18" dur="1" fill="hold">
+                                          <p:stCondLst>
+                                            <p:cond delay="0"/>
+                                          </p:stCondLst>
+                                        </p:cTn>
+                                        <p:tgtEl>
+                                          <p:spTgt spid="3">
+                                            <p:txEl>
+                                              <p:pRg st="3" end="3"/>
+                                            </p:txEl>
+                                          </p:spTgt>
+                                        </p:tgtEl>
+                                        <p:attrNameLst>
+                                          <p:attrName>style.visibility</p:attrName>
+                                        </p:attrNameLst>
+                                      </p:cBhvr>
+                                      <p:to>
+                                        <p:strVal val="visible"/>
+                                      </p:to>
+                                    </p:set>
+                                  </p:childTnLst>
+                                </p:cTn>
+                              </p:par>
+                            </p:childTnLst>
+                          </p:cTn>
+                        </p:par>
+                      </p:childTnLst>
+                    </p:cTn>
+                  </p:par>
+                  <p:par>
+                    <p:cTn id="19" fill="hold">
+                      <p:stCondLst>
+                        <p:cond delay="indefinite"/>
+                      </p:stCondLst>
+                      <p:childTnLst>
+                        <p:par>
+                          <p:cTn id="20" fill="hold">
+                            <p:stCondLst>
+                              <p:cond delay="0"/>
+                            </p:stCondLst>
+                            <p:childTnLst>
+                              <p:par>
+                                <p:cTn id="21" presetID="1" presetClass="entr" presetSubtype="0" fill="hold" nodeType="clickEffect">
+                                  <p:stCondLst>
+                                    <p:cond delay="0"/>
+                                  </p:stCondLst>
+                                  <p:childTnLst>
+                                    <p:set>
+                                      <p:cBhvr>
+                                        <p:cTn id="22" dur="1" fill="hold">
+                                          <p:stCondLst>
+                                            <p:cond delay="0"/>
+                                          </p:stCondLst>
+                                        </p:cTn>
+                                        <p:tgtEl>
+                                          <p:spTgt spid="3">
+                                            <p:txEl>
+                                              <p:pRg st="4" end="4"/>
+                                            </p:txEl>
+                                          </p:spTgt>
+                                        </p:tgtEl>
+                                        <p:attrNameLst>
+                                          <p:attrName>style.visibility</p:attrName>
+                                        </p:attrNameLst>
+                                      </p:cBhvr>
+                                      <p:to>
+                                        <p:strVal val="visible"/>
+                                      </p:to>
+                                    </p:set>
+                                  </p:childTnLst>
+                                </p:cTn>
+                              </p:par>
+                            </p:childTnLst>
+                          </p:cTn>
+                        </p:par>
+                      </p:childTnLst>
+                    </p:cTn>
+                  </p:par>
+                </p:childTnLst>
+              </p:cTn>
+              <p:prevCondLst>
+                <p:cond evt="onPrev" delay="0">
+                  <p:tgtEl>
+                    <p:sldTgt/>
+                  </p:tgtEl>
+                </p:cond>
+              </p:prevCondLst>
+              <p:nextCondLst>
+                <p:cond evt="onNext" delay="0">
+                  <p:tgtEl>
+                    <p:sldTgt/>
+                  </p:tgtEl>
+                </p:cond>
+              </p:nextCondLst>
+            </p:seq>
+          </p:childTnLst>
+        </p:cTn>
+      </p:par>
+    </p:tnLst>
+  </p:timing>
+</p:sld>
+</file>
+
+<file path=ppt/slides/slide14.xml><?xml version="1.0" encoding="utf-8"?>
+<p:sld xmlns:a="http://schemas.openxmlformats.org/drawingml/2006/main" xmlns:r="http://schemas.openxmlformats.org/officeDocument/2006/relationships" xmlns:p="http://schemas.openxmlformats.org/presentationml/2006/main">
+  <p:cSld>
+    <p:spTree>
+      <p:nvGrpSpPr>
+        <p:cNvPr id="1" name=""/>
+        <p:cNvGrpSpPr/>
+        <p:nvPr/>
+      </p:nvGrpSpPr>
+      <p:grpSpPr>
+        <a:xfrm>
+          <a:off x="0" y="0"/>
+          <a:ext cx="0" cy="0"/>
+          <a:chOff x="0" y="0"/>
+          <a:chExt cx="0" cy="0"/>
+        </a:xfrm>
+      </p:grpSpPr>
+      <p:sp>
+        <p:nvSpPr>
+          <p:cNvPr id="2" name="Title 1">
+            <a:extLst>
+              <a:ext uri="{FF2B5EF4-FFF2-40B4-BE49-F238E27FC236}">
+                <a16:creationId xmlns:a16="http://schemas.microsoft.com/office/drawing/2014/main" id="{F2D7A849-16BD-A6C4-D1A7-81CC871102F5}"/>
+              </a:ext>
+            </a:extLst>
+          </p:cNvPr>
+          <p:cNvSpPr>
+            <a:spLocks noGrp="1"/>
+          </p:cNvSpPr>
+          <p:nvPr>
+            <p:ph type="title"/>
+          </p:nvPr>
+        </p:nvSpPr>
+        <p:spPr/>
+        <p:txBody>
+          <a:bodyPr/>
+          <a:lstStyle/>
+          <a:p>
+            <a:r>
+              <a:rPr lang="en-US" dirty="0"/>
+              <a:t>Synthetic Data Experiments</a:t>
+            </a:r>
+          </a:p>
+        </p:txBody>
+      </p:sp>
+      <mc:AlternateContent xmlns:mc="http://schemas.openxmlformats.org/markup-compatibility/2006">
+        <mc:Choice xmlns:a14="http://schemas.microsoft.com/office/drawing/2010/main" Requires="a14">
+          <p:graphicFrame>
+            <p:nvGraphicFramePr>
+              <p:cNvPr id="6" name="Content Placeholder 5">
+                <a:extLst>
+                  <a:ext uri="{FF2B5EF4-FFF2-40B4-BE49-F238E27FC236}">
+                    <a16:creationId xmlns:a16="http://schemas.microsoft.com/office/drawing/2014/main" id="{4B4429C7-214A-BF5B-3F75-7D3A038B6F82}"/>
+                  </a:ext>
+                </a:extLst>
+              </p:cNvPr>
+              <p:cNvGraphicFramePr>
+                <a:graphicFrameLocks noGrp="1"/>
+              </p:cNvGraphicFramePr>
+              <p:nvPr>
+                <p:ph idx="1"/>
+                <p:extLst>
+                  <p:ext uri="{D42A27DB-BD31-4B8C-83A1-F6EECF244321}">
+                    <p14:modId xmlns:p14="http://schemas.microsoft.com/office/powerpoint/2010/main" val="2832712761"/>
+                  </p:ext>
+                </p:extLst>
+              </p:nvPr>
+            </p:nvGraphicFramePr>
+            <p:xfrm>
+              <a:off x="838199" y="1825625"/>
+              <a:ext cx="10639098" cy="2793672"/>
+            </p:xfrm>
+            <a:graphic>
+              <a:graphicData uri="http://schemas.openxmlformats.org/drawingml/2006/table">
+                <a:tbl>
+                  <a:tblPr firstRow="1" bandRow="1">
+                    <a:tableStyleId>{5C22544A-7EE6-4342-B048-85BDC9FD1C3A}</a:tableStyleId>
+                  </a:tblPr>
+                  <a:tblGrid>
+                    <a:gridCol w="5319549">
+                      <a:extLst>
+                        <a:ext uri="{9D8B030D-6E8A-4147-A177-3AD203B41FA5}">
+                          <a16:colId xmlns:a16="http://schemas.microsoft.com/office/drawing/2014/main" val="2418271835"/>
+                        </a:ext>
+                      </a:extLst>
+                    </a:gridCol>
+                    <a:gridCol w="5319549">
+                      <a:extLst>
+                        <a:ext uri="{9D8B030D-6E8A-4147-A177-3AD203B41FA5}">
+                          <a16:colId xmlns:a16="http://schemas.microsoft.com/office/drawing/2014/main" val="3761334250"/>
+                        </a:ext>
+                      </a:extLst>
+                    </a:gridCol>
+                  </a:tblGrid>
+                  <a:tr h="488723">
+                    <a:tc>
+                      <a:txBody>
+                        <a:bodyPr/>
+                        <a:lstStyle/>
+                        <a:p>
+                          <a:r>
+                            <a:rPr lang="en-US" dirty="0"/>
+                            <a:t>Quantity</a:t>
+                          </a:r>
+                        </a:p>
+                      </a:txBody>
+                      <a:tcPr/>
+                    </a:tc>
+                    <a:tc>
+                      <a:txBody>
+                        <a:bodyPr/>
+                        <a:lstStyle/>
+                        <a:p>
+                          <a:r>
+                            <a:rPr lang="en-US" dirty="0"/>
+                            <a:t>Distribution / Definition</a:t>
+                          </a:r>
+                        </a:p>
+                      </a:txBody>
+                      <a:tcPr/>
+                    </a:tc>
+                    <a:extLst>
+                      <a:ext uri="{0D108BD9-81ED-4DB2-BD59-A6C34878D82A}">
+                        <a16:rowId xmlns:a16="http://schemas.microsoft.com/office/drawing/2014/main" val="4222401980"/>
+                      </a:ext>
+                    </a:extLst>
+                  </a:tr>
+                  <a:tr h="488723">
+                    <a:tc>
+                      <a:txBody>
+                        <a:bodyPr/>
+                        <a:lstStyle/>
+                        <a:p>
+                          <a:r>
+                            <a:rPr lang="en-US" dirty="0"/>
+                            <a:t>Population size</a:t>
+                          </a:r>
+                        </a:p>
+                      </a:txBody>
+                      <a:tcPr/>
+                    </a:tc>
+                    <a:tc>
+                      <a:txBody>
+                        <a:bodyPr/>
+                        <a:lstStyle/>
+                        <a:p>
+                          <a:pPr algn="ctr"/>
+                          <a:r>
+                            <a:rPr lang="en-US" dirty="0"/>
+                            <a:t>m (fixed)</a:t>
+                          </a:r>
+                        </a:p>
+                      </a:txBody>
+                      <a:tcPr/>
+                    </a:tc>
+                    <a:extLst>
+                      <a:ext uri="{0D108BD9-81ED-4DB2-BD59-A6C34878D82A}">
+                        <a16:rowId xmlns:a16="http://schemas.microsoft.com/office/drawing/2014/main" val="2934207172"/>
+                      </a:ext>
+                    </a:extLst>
+                  </a:tr>
+                  <a:tr h="488723">
+                    <a:tc>
+                      <a:txBody>
+                        <a:bodyPr/>
+                        <a:lstStyle/>
+                        <a:p>
+                          <a:r>
+                            <a:rPr lang="en-US" dirty="0"/>
+                            <a:t>Treatment Assignment</a:t>
+                          </a:r>
+                        </a:p>
+                      </a:txBody>
+                      <a:tcPr/>
+                    </a:tc>
+                    <a:tc>
+                      <a:txBody>
+                        <a:bodyPr/>
+                        <a:lstStyle/>
+                        <a:p>
+                          <a:pPr algn="ctr"/>
+                          <a14:m>
+                            <m:oMath xmlns:m="http://schemas.openxmlformats.org/officeDocument/2006/math">
+                              <m:sSub>
+                                <m:sSubPr>
+                                  <m:ctrlPr>
+                                    <a:rPr lang="en-US" i="1" dirty="0" smtClean="0">
+                                      <a:latin typeface="Cambria Math" panose="02040503050406030204" pitchFamily="18" charset="0"/>
+                                    </a:rPr>
+                                  </m:ctrlPr>
+                                </m:sSubPr>
+                                <m:e>
+                                  <m:r>
+                                    <a:rPr lang="en-US" i="1" dirty="0" smtClean="0">
+                                      <a:latin typeface="Cambria Math" panose="02040503050406030204" pitchFamily="18" charset="0"/>
+                                    </a:rPr>
+                                    <m:t>𝑍</m:t>
+                                  </m:r>
+                                </m:e>
+                                <m:sub>
+                                  <m:r>
+                                    <a:rPr lang="en-US" i="1" dirty="0" smtClean="0">
+                                      <a:latin typeface="Cambria Math" panose="02040503050406030204" pitchFamily="18" charset="0"/>
+                                    </a:rPr>
+                                    <m:t>𝑖</m:t>
+                                  </m:r>
+                                </m:sub>
+                              </m:sSub>
+                              <m:r>
+                                <a:rPr lang="en-US" i="1" dirty="0" smtClean="0">
+                                  <a:latin typeface="Cambria Math" panose="02040503050406030204" pitchFamily="18" charset="0"/>
+                                </a:rPr>
+                                <m:t>∼</m:t>
+                              </m:r>
+                            </m:oMath>
+                          </a14:m>
+                          <a:r>
+                            <a:rPr lang="en-US" dirty="0"/>
+                            <a:t>Bernoulli(0.5)</a:t>
+                          </a:r>
+                        </a:p>
+                      </a:txBody>
+                      <a:tcPr/>
+                    </a:tc>
+                    <a:extLst>
+                      <a:ext uri="{0D108BD9-81ED-4DB2-BD59-A6C34878D82A}">
+                        <a16:rowId xmlns:a16="http://schemas.microsoft.com/office/drawing/2014/main" val="1723975838"/>
+                      </a:ext>
+                    </a:extLst>
+                  </a:tr>
+                  <a:tr h="838780">
+                    <a:tc>
+                      <a:txBody>
+                        <a:bodyPr/>
+                        <a:lstStyle/>
+                        <a:p>
+                          <a:r>
+                            <a:rPr lang="en-US" dirty="0"/>
+                            <a:t>Potential Outcomes</a:t>
+                          </a:r>
+                        </a:p>
+                      </a:txBody>
+                      <a:tcPr/>
+                    </a:tc>
+                    <a:tc>
+                      <a:txBody>
+                        <a:bodyPr/>
+                        <a:lstStyle/>
+                        <a:p>
+                          <a:pPr/>
+                          <a14:m>
+                            <m:oMathPara xmlns:m="http://schemas.openxmlformats.org/officeDocument/2006/math">
+                              <m:oMathParaPr>
+                                <m:jc m:val="centerGroup"/>
+                              </m:oMathParaPr>
+                              <m:oMath xmlns:m="http://schemas.openxmlformats.org/officeDocument/2006/math">
+                                <m:m>
+                                  <m:mPr>
+                                    <m:plcHide m:val="on"/>
+                                    <m:mcs>
+                                      <m:mc>
+                                        <m:mcPr>
+                                          <m:count m:val="1"/>
+                                          <m:mcJc m:val="center"/>
+                                        </m:mcPr>
+                                      </m:mc>
+                                    </m:mcs>
+                                    <m:ctrlPr>
+                                      <a:rPr lang="en-US" b="0" i="1" smtClean="0">
+                                        <a:latin typeface="Cambria Math" panose="02040503050406030204" pitchFamily="18" charset="0"/>
+                                      </a:rPr>
+                                    </m:ctrlPr>
+                                  </m:mPr>
+                                  <m:mr>
+                                    <m:e>
+                                      <m:sSub>
+                                        <m:sSubPr>
+                                          <m:ctrlPr>
+                                            <a:rPr lang="en-US" b="0" i="1" smtClean="0">
+                                              <a:latin typeface="Cambria Math" panose="02040503050406030204" pitchFamily="18" charset="0"/>
+                                            </a:rPr>
+                                          </m:ctrlPr>
+                                        </m:sSubPr>
+                                        <m:e>
+                                          <m:r>
+                                            <a:rPr lang="en-US" b="0" i="1" smtClean="0">
+                                              <a:latin typeface="Cambria Math" panose="02040503050406030204" pitchFamily="18" charset="0"/>
+                                            </a:rPr>
+                                            <m:t>𝑌</m:t>
+                                          </m:r>
+                                        </m:e>
+                                        <m:sub>
+                                          <m:r>
+                                            <a:rPr lang="en-US" b="0" i="1" smtClean="0">
+                                              <a:latin typeface="Cambria Math" panose="02040503050406030204" pitchFamily="18" charset="0"/>
+                                            </a:rPr>
+                                            <m:t>𝑖</m:t>
+                                          </m:r>
+                                        </m:sub>
+                                      </m:sSub>
+                                      <m:d>
+                                        <m:dPr>
+                                          <m:ctrlPr>
+                                            <a:rPr lang="en-US" b="0" i="1" smtClean="0">
+                                              <a:latin typeface="Cambria Math" panose="02040503050406030204" pitchFamily="18" charset="0"/>
+                                            </a:rPr>
+                                          </m:ctrlPr>
+                                        </m:dPr>
+                                        <m:e>
+                                          <m:r>
+                                            <a:rPr lang="en-US" b="0" i="1" smtClean="0">
+                                              <a:latin typeface="Cambria Math" panose="02040503050406030204" pitchFamily="18" charset="0"/>
+                                            </a:rPr>
+                                            <m:t>0</m:t>
+                                          </m:r>
+                                        </m:e>
+                                      </m:d>
+                                    </m:e>
+                                  </m:mr>
+                                  <m:mr>
+                                    <m:e>
+                                      <m:sSub>
+                                        <m:sSubPr>
+                                          <m:ctrlPr>
+                                            <a:rPr lang="en-US" b="0" i="1" smtClean="0">
+                                              <a:latin typeface="Cambria Math" panose="02040503050406030204" pitchFamily="18" charset="0"/>
+                                            </a:rPr>
+                                          </m:ctrlPr>
+                                        </m:sSubPr>
+                                        <m:e>
+                                          <m:r>
+                                            <a:rPr lang="en-US" b="0" i="1" smtClean="0">
+                                              <a:latin typeface="Cambria Math" panose="02040503050406030204" pitchFamily="18" charset="0"/>
+                                            </a:rPr>
+                                            <m:t>𝑌</m:t>
+                                          </m:r>
+                                        </m:e>
+                                        <m:sub>
+                                          <m:r>
+                                            <a:rPr lang="en-US" b="0" i="1" smtClean="0">
+                                              <a:latin typeface="Cambria Math" panose="02040503050406030204" pitchFamily="18" charset="0"/>
+                                            </a:rPr>
+                                            <m:t>𝑖</m:t>
+                                          </m:r>
+                                        </m:sub>
+                                      </m:sSub>
+                                      <m:d>
+                                        <m:dPr>
+                                          <m:ctrlPr>
+                                            <a:rPr lang="en-US" b="0" i="1" smtClean="0">
+                                              <a:latin typeface="Cambria Math" panose="02040503050406030204" pitchFamily="18" charset="0"/>
+                                            </a:rPr>
+                                          </m:ctrlPr>
+                                        </m:dPr>
+                                        <m:e>
+                                          <m:r>
+                                            <a:rPr lang="en-US" b="0" i="1" smtClean="0">
+                                              <a:latin typeface="Cambria Math" panose="02040503050406030204" pitchFamily="18" charset="0"/>
+                                            </a:rPr>
+                                            <m:t>1</m:t>
+                                          </m:r>
+                                        </m:e>
+                                      </m:d>
+                                    </m:e>
+                                  </m:mr>
+                                </m:m>
+                                <m:r>
+                                  <a:rPr lang="en-US" b="0" i="1" smtClean="0">
+                                    <a:latin typeface="Cambria Math" panose="02040503050406030204" pitchFamily="18" charset="0"/>
+                                  </a:rPr>
+                                  <m:t> ∼ </m:t>
+                                </m:r>
+                                <m:r>
+                                  <m:rPr>
+                                    <m:sty m:val="p"/>
+                                  </m:rPr>
+                                  <a:rPr lang="en-US" b="0" i="1" smtClean="0">
+                                    <a:latin typeface="Cambria Math" panose="02040503050406030204" pitchFamily="18" charset="0"/>
+                                  </a:rPr>
+                                  <m:t>N</m:t>
+                                </m:r>
+                                <m:r>
+                                  <a:rPr lang="en-US" b="0" i="1" smtClean="0">
+                                    <a:latin typeface="Cambria Math" panose="02040503050406030204" pitchFamily="18" charset="0"/>
+                                  </a:rPr>
+                                  <m:t> </m:t>
+                                </m:r>
+                                <m:d>
+                                  <m:dPr>
+                                    <m:ctrlPr>
+                                      <a:rPr lang="en-US" b="0" i="1" smtClean="0">
+                                        <a:latin typeface="Cambria Math" panose="02040503050406030204" pitchFamily="18" charset="0"/>
+                                      </a:rPr>
+                                    </m:ctrlPr>
+                                  </m:dPr>
+                                  <m:e>
+                                    <m:m>
+                                      <m:mPr>
+                                        <m:mcs>
+                                          <m:mc>
+                                            <m:mcPr>
+                                              <m:count m:val="1"/>
+                                              <m:mcJc m:val="center"/>
+                                            </m:mcPr>
+                                          </m:mc>
+                                        </m:mcs>
+                                        <m:ctrlPr>
+                                          <a:rPr lang="en-US" b="0" i="1" smtClean="0">
+                                            <a:latin typeface="Cambria Math" panose="02040503050406030204" pitchFamily="18" charset="0"/>
+                                          </a:rPr>
+                                        </m:ctrlPr>
+                                      </m:mPr>
+                                      <m:mr>
+                                        <m:e>
+                                          <m:r>
+                                            <m:rPr>
+                                              <m:brk m:alnAt="7"/>
+                                            </m:rPr>
+                                            <a:rPr lang="en-US" b="0" i="1" smtClean="0">
+                                              <a:latin typeface="Cambria Math" panose="02040503050406030204" pitchFamily="18" charset="0"/>
+                                            </a:rPr>
+                                            <m:t>0</m:t>
+                                          </m:r>
+                                        </m:e>
+                                      </m:mr>
+                                      <m:mr>
+                                        <m:e>
+                                          <m:sSub>
+                                            <m:sSubPr>
+                                              <m:ctrlPr>
+                                                <a:rPr lang="en-US" b="0" i="1" smtClean="0">
+                                                  <a:latin typeface="Cambria Math" panose="02040503050406030204" pitchFamily="18" charset="0"/>
+                                                </a:rPr>
+                                              </m:ctrlPr>
+                                            </m:sSubPr>
+                                            <m:e>
+                                              <m:r>
+                                                <a:rPr lang="en-US" b="0" i="1" smtClean="0">
+                                                  <a:latin typeface="Cambria Math" panose="02040503050406030204" pitchFamily="18" charset="0"/>
+                                                </a:rPr>
+                                                <m:t>𝜏</m:t>
+                                              </m:r>
+                                            </m:e>
+                                            <m:sub>
+                                              <m:r>
+                                                <a:rPr lang="en-US" b="0" i="1" smtClean="0">
+                                                  <a:latin typeface="Cambria Math" panose="02040503050406030204" pitchFamily="18" charset="0"/>
+                                                </a:rPr>
+                                                <m:t>0</m:t>
+                                              </m:r>
+                                            </m:sub>
+                                          </m:sSub>
+                                        </m:e>
+                                      </m:mr>
+                                    </m:m>
+                                    <m:r>
+                                      <a:rPr lang="en-US" b="0" i="1" smtClean="0">
+                                        <a:latin typeface="Cambria Math" panose="02040503050406030204" pitchFamily="18" charset="0"/>
+                                      </a:rPr>
+                                      <m:t>,</m:t>
+                                    </m:r>
+                                    <m:m>
+                                      <m:mPr>
+                                        <m:mcs>
+                                          <m:mc>
+                                            <m:mcPr>
+                                              <m:count m:val="2"/>
+                                              <m:mcJc m:val="center"/>
+                                            </m:mcPr>
+                                          </m:mc>
+                                        </m:mcs>
+                                        <m:ctrlPr>
+                                          <a:rPr lang="en-US" b="0" i="1" smtClean="0">
+                                            <a:latin typeface="Cambria Math" panose="02040503050406030204" pitchFamily="18" charset="0"/>
+                                          </a:rPr>
+                                        </m:ctrlPr>
+                                      </m:mPr>
+                                      <m:mr>
+                                        <m:e>
+                                          <m:r>
+                                            <m:rPr>
+                                              <m:brk m:alnAt="7"/>
+                                            </m:rPr>
+                                            <a:rPr lang="en-US" b="0" i="1" smtClean="0">
+                                              <a:latin typeface="Cambria Math" panose="02040503050406030204" pitchFamily="18" charset="0"/>
+                                            </a:rPr>
+                                            <m:t>1</m:t>
+                                          </m:r>
+                                        </m:e>
+                                        <m:e>
+                                          <m:r>
+                                            <a:rPr lang="en-US" b="0" i="1" smtClean="0">
+                                              <a:latin typeface="Cambria Math" panose="02040503050406030204" pitchFamily="18" charset="0"/>
+                                            </a:rPr>
+                                            <m:t>𝜌</m:t>
+                                          </m:r>
+                                        </m:e>
+                                      </m:mr>
+                                      <m:mr>
+                                        <m:e>
+                                          <m:r>
+                                            <a:rPr lang="en-US" b="0" i="1" smtClean="0">
+                                              <a:latin typeface="Cambria Math" panose="02040503050406030204" pitchFamily="18" charset="0"/>
+                                            </a:rPr>
+                                            <m:t>𝜌</m:t>
+                                          </m:r>
+                                        </m:e>
+                                        <m:e>
+                                          <m:r>
+                                            <a:rPr lang="en-US" b="0" i="1" smtClean="0">
+                                              <a:latin typeface="Cambria Math" panose="02040503050406030204" pitchFamily="18" charset="0"/>
+                                            </a:rPr>
+                                            <m:t>1</m:t>
+                                          </m:r>
+                                        </m:e>
+                                      </m:mr>
+                                    </m:m>
+                                  </m:e>
+                                </m:d>
+                              </m:oMath>
+                            </m:oMathPara>
+                          </a14:m>
+                        </a:p>
+                      </a:txBody>
+                      <a:tcPr/>
+                    </a:tc>
+                    <a:extLst>
+                      <a:ext uri="{0D108BD9-81ED-4DB2-BD59-A6C34878D82A}">
+                        <a16:rowId xmlns:a16="http://schemas.microsoft.com/office/drawing/2014/main" val="757081235"/>
+                      </a:ext>
+                    </a:extLst>
+                  </a:tr>
+                  <a:tr h="488723">
+                    <a:tc>
+                      <a:txBody>
+                        <a:bodyPr/>
+                        <a:lstStyle/>
+                        <a:p>
+                          <a:r>
+                            <a:rPr lang="en-US" dirty="0"/>
+                            <a:t>Observed Outcome</a:t>
+                          </a:r>
+                        </a:p>
+                      </a:txBody>
+                      <a:tcPr/>
+                    </a:tc>
+                    <a:tc>
+                      <a:txBody>
+                        <a:bodyPr/>
+                        <a:lstStyle/>
+                        <a:p>
+                          <a14:m>
+                            <m:oMathPara xmlns:m="http://schemas.openxmlformats.org/officeDocument/2006/math">
+                              <m:oMathParaPr>
+                                <m:jc m:val="centerGroup"/>
+                              </m:oMathParaPr>
+                              <m:oMath xmlns:m="http://schemas.openxmlformats.org/officeDocument/2006/math">
+                                <m:sSub>
+                                  <m:sSubPr>
+                                    <m:ctrlPr>
+                                      <a:rPr lang="en-US" i="1" dirty="0" smtClean="0">
+                                        <a:latin typeface="Cambria Math" panose="02040503050406030204" pitchFamily="18" charset="0"/>
+                                      </a:rPr>
+                                    </m:ctrlPr>
+                                  </m:sSubPr>
+                                  <m:e>
+                                    <m:r>
+                                      <a:rPr lang="en-US" i="1" dirty="0" smtClean="0">
+                                        <a:latin typeface="Cambria Math" panose="02040503050406030204" pitchFamily="18" charset="0"/>
+                                      </a:rPr>
+                                      <m:t>𝑌</m:t>
+                                    </m:r>
+                                  </m:e>
+                                  <m:sub>
+                                    <m:r>
+                                      <a:rPr lang="en-US" i="1" dirty="0" smtClean="0">
+                                        <a:latin typeface="Cambria Math" panose="02040503050406030204" pitchFamily="18" charset="0"/>
+                                      </a:rPr>
+                                      <m:t>𝑖</m:t>
+                                    </m:r>
+                                  </m:sub>
+                                </m:sSub>
+                                <m:r>
+                                  <a:rPr lang="en-US" i="1" dirty="0" smtClean="0">
+                                    <a:latin typeface="Cambria Math" panose="02040503050406030204" pitchFamily="18" charset="0"/>
+                                  </a:rPr>
+                                  <m:t>=</m:t>
+                                </m:r>
+                                <m:sSub>
+                                  <m:sSubPr>
+                                    <m:ctrlPr>
+                                      <a:rPr lang="en-US" i="1" dirty="0" err="1" smtClean="0">
+                                        <a:latin typeface="Cambria Math" panose="02040503050406030204" pitchFamily="18" charset="0"/>
+                                      </a:rPr>
+                                    </m:ctrlPr>
+                                  </m:sSubPr>
+                                  <m:e>
+                                    <m:r>
+                                      <a:rPr lang="en-US" i="1" dirty="0" err="1" smtClean="0">
+                                        <a:latin typeface="Cambria Math" panose="02040503050406030204" pitchFamily="18" charset="0"/>
+                                      </a:rPr>
+                                      <m:t>𝑌</m:t>
+                                    </m:r>
+                                  </m:e>
+                                  <m:sub>
+                                    <m:r>
+                                      <a:rPr lang="en-US" i="1" dirty="0" err="1" smtClean="0">
+                                        <a:latin typeface="Cambria Math" panose="02040503050406030204" pitchFamily="18" charset="0"/>
+                                      </a:rPr>
+                                      <m:t>𝑖</m:t>
+                                    </m:r>
+                                  </m:sub>
+                                </m:sSub>
+                                <m:d>
+                                  <m:dPr>
+                                    <m:ctrlPr>
+                                      <a:rPr lang="en-US" i="1" dirty="0" smtClean="0">
+                                        <a:latin typeface="Cambria Math" panose="02040503050406030204" pitchFamily="18" charset="0"/>
+                                      </a:rPr>
+                                    </m:ctrlPr>
+                                  </m:dPr>
+                                  <m:e>
+                                    <m:r>
+                                      <a:rPr lang="en-US" i="1" dirty="0" smtClean="0">
+                                        <a:latin typeface="Cambria Math" panose="02040503050406030204" pitchFamily="18" charset="0"/>
+                                      </a:rPr>
+                                      <m:t>1</m:t>
+                                    </m:r>
+                                  </m:e>
+                                </m:d>
+                                <m:sSub>
+                                  <m:sSubPr>
+                                    <m:ctrlPr>
+                                      <a:rPr lang="en-US" i="1" dirty="0" err="1" smtClean="0">
+                                        <a:latin typeface="Cambria Math" panose="02040503050406030204" pitchFamily="18" charset="0"/>
+                                      </a:rPr>
+                                    </m:ctrlPr>
+                                  </m:sSubPr>
+                                  <m:e>
+                                    <m:r>
+                                      <a:rPr lang="en-US" i="1" dirty="0" err="1" smtClean="0">
+                                        <a:latin typeface="Cambria Math" panose="02040503050406030204" pitchFamily="18" charset="0"/>
+                                      </a:rPr>
+                                      <m:t>𝑍</m:t>
+                                    </m:r>
+                                  </m:e>
+                                  <m:sub>
+                                    <m:r>
+                                      <a:rPr lang="en-US" i="1" dirty="0" err="1" smtClean="0">
+                                        <a:latin typeface="Cambria Math" panose="02040503050406030204" pitchFamily="18" charset="0"/>
+                                      </a:rPr>
+                                      <m:t>𝑖</m:t>
+                                    </m:r>
+                                  </m:sub>
+                                </m:sSub>
+                                <m:r>
+                                  <a:rPr lang="en-US" i="1" dirty="0" smtClean="0">
+                                    <a:latin typeface="Cambria Math" panose="02040503050406030204" pitchFamily="18" charset="0"/>
+                                  </a:rPr>
+                                  <m:t>+</m:t>
+                                </m:r>
+                                <m:sSub>
+                                  <m:sSubPr>
+                                    <m:ctrlPr>
+                                      <a:rPr lang="en-US" i="1" dirty="0" err="1" smtClean="0">
+                                        <a:latin typeface="Cambria Math" panose="02040503050406030204" pitchFamily="18" charset="0"/>
+                                      </a:rPr>
+                                    </m:ctrlPr>
+                                  </m:sSubPr>
+                                  <m:e>
+                                    <m:r>
+                                      <a:rPr lang="en-US" i="1" dirty="0" err="1" smtClean="0">
+                                        <a:latin typeface="Cambria Math" panose="02040503050406030204" pitchFamily="18" charset="0"/>
+                                      </a:rPr>
+                                      <m:t>𝑌</m:t>
+                                    </m:r>
+                                  </m:e>
+                                  <m:sub>
+                                    <m:r>
+                                      <a:rPr lang="en-US" i="1" dirty="0" err="1" smtClean="0">
+                                        <a:latin typeface="Cambria Math" panose="02040503050406030204" pitchFamily="18" charset="0"/>
+                                      </a:rPr>
+                                      <m:t>𝑖</m:t>
+                                    </m:r>
+                                  </m:sub>
+                                </m:sSub>
+                                <m:d>
+                                  <m:dPr>
+                                    <m:ctrlPr>
+                                      <a:rPr lang="en-US" i="1" dirty="0" smtClean="0">
+                                        <a:latin typeface="Cambria Math" panose="02040503050406030204" pitchFamily="18" charset="0"/>
+                                      </a:rPr>
+                                    </m:ctrlPr>
+                                  </m:dPr>
+                                  <m:e>
+                                    <m:r>
+                                      <a:rPr lang="en-US" i="1" dirty="0" smtClean="0">
+                                        <a:latin typeface="Cambria Math" panose="02040503050406030204" pitchFamily="18" charset="0"/>
+                                      </a:rPr>
+                                      <m:t>0</m:t>
+                                    </m:r>
+                                  </m:e>
+                                </m:d>
+                                <m:d>
+                                  <m:dPr>
+                                    <m:ctrlPr>
+                                      <a:rPr lang="en-US" i="1" dirty="0" smtClean="0">
+                                        <a:latin typeface="Cambria Math" panose="02040503050406030204" pitchFamily="18" charset="0"/>
+                                      </a:rPr>
+                                    </m:ctrlPr>
+                                  </m:dPr>
+                                  <m:e>
+                                    <m:r>
+                                      <a:rPr lang="en-US" i="1" dirty="0" smtClean="0">
+                                        <a:latin typeface="Cambria Math" panose="02040503050406030204" pitchFamily="18" charset="0"/>
+                                      </a:rPr>
+                                      <m:t>1−</m:t>
+                                    </m:r>
+                                    <m:sSub>
+                                      <m:sSubPr>
+                                        <m:ctrlPr>
+                                          <a:rPr lang="en-US" i="1" dirty="0" smtClean="0">
+                                            <a:latin typeface="Cambria Math" panose="02040503050406030204" pitchFamily="18" charset="0"/>
+                                          </a:rPr>
+                                        </m:ctrlPr>
+                                      </m:sSubPr>
+                                      <m:e>
+                                        <m:r>
+                                          <a:rPr lang="en-US" i="1" dirty="0" smtClean="0">
+                                            <a:latin typeface="Cambria Math" panose="02040503050406030204" pitchFamily="18" charset="0"/>
+                                          </a:rPr>
+                                          <m:t>𝑍</m:t>
+                                        </m:r>
+                                      </m:e>
+                                      <m:sub>
+                                        <m:r>
+                                          <a:rPr lang="en-US" i="1" dirty="0" smtClean="0">
+                                            <a:latin typeface="Cambria Math" panose="02040503050406030204" pitchFamily="18" charset="0"/>
+                                          </a:rPr>
+                                          <m:t>𝑖</m:t>
+                                        </m:r>
+                                      </m:sub>
+                                    </m:sSub>
+                                  </m:e>
+                                </m:d>
+                              </m:oMath>
+                            </m:oMathPara>
+                          </a14:m>
+                        </a:p>
+                      </a:txBody>
+                      <a:tcPr/>
+                    </a:tc>
+                    <a:extLst>
+                      <a:ext uri="{0D108BD9-81ED-4DB2-BD59-A6C34878D82A}">
+                        <a16:rowId xmlns:a16="http://schemas.microsoft.com/office/drawing/2014/main" val="3172079154"/>
+                      </a:ext>
+                    </a:extLst>
+                  </a:tr>
+                </a:tbl>
+              </a:graphicData>
+            </a:graphic>
+          </p:graphicFrame>
+        </mc:Choice>
+        <mc:Fallback>
+          <p:graphicFrame>
+            <p:nvGraphicFramePr>
+              <p:cNvPr id="6" name="Content Placeholder 5">
+                <a:extLst>
+                  <a:ext uri="{FF2B5EF4-FFF2-40B4-BE49-F238E27FC236}">
+                    <a16:creationId xmlns:a16="http://schemas.microsoft.com/office/drawing/2014/main" id="{4B4429C7-214A-BF5B-3F75-7D3A038B6F82}"/>
+                  </a:ext>
+                </a:extLst>
+              </p:cNvPr>
+              <p:cNvGraphicFramePr>
+                <a:graphicFrameLocks noGrp="1"/>
+              </p:cNvGraphicFramePr>
+              <p:nvPr>
+                <p:ph idx="1"/>
+                <p:extLst>
+                  <p:ext uri="{D42A27DB-BD31-4B8C-83A1-F6EECF244321}">
+                    <p14:modId xmlns:p14="http://schemas.microsoft.com/office/powerpoint/2010/main" val="2832712761"/>
+                  </p:ext>
+                </p:extLst>
+              </p:nvPr>
+            </p:nvGraphicFramePr>
+            <p:xfrm>
+              <a:off x="838199" y="1825625"/>
+              <a:ext cx="10639098" cy="2793672"/>
+            </p:xfrm>
+            <a:graphic>
+              <a:graphicData uri="http://schemas.openxmlformats.org/drawingml/2006/table">
+                <a:tbl>
+                  <a:tblPr firstRow="1" bandRow="1">
+                    <a:tableStyleId>{5C22544A-7EE6-4342-B048-85BDC9FD1C3A}</a:tableStyleId>
+                  </a:tblPr>
+                  <a:tblGrid>
+                    <a:gridCol w="5319549">
+                      <a:extLst>
+                        <a:ext uri="{9D8B030D-6E8A-4147-A177-3AD203B41FA5}">
+                          <a16:colId xmlns:a16="http://schemas.microsoft.com/office/drawing/2014/main" val="2418271835"/>
+                        </a:ext>
+                      </a:extLst>
+                    </a:gridCol>
+                    <a:gridCol w="5319549">
+                      <a:extLst>
+                        <a:ext uri="{9D8B030D-6E8A-4147-A177-3AD203B41FA5}">
+                          <a16:colId xmlns:a16="http://schemas.microsoft.com/office/drawing/2014/main" val="3761334250"/>
+                        </a:ext>
+                      </a:extLst>
+                    </a:gridCol>
+                  </a:tblGrid>
+                  <a:tr h="488723">
+                    <a:tc>
+                      <a:txBody>
+                        <a:bodyPr/>
+                        <a:lstStyle/>
+                        <a:p>
+                          <a:r>
+                            <a:rPr lang="en-US" dirty="0"/>
+                            <a:t>Quantity</a:t>
+                          </a:r>
+                        </a:p>
+                      </a:txBody>
+                      <a:tcPr/>
+                    </a:tc>
+                    <a:tc>
+                      <a:txBody>
+                        <a:bodyPr/>
+                        <a:lstStyle/>
+                        <a:p>
+                          <a:r>
+                            <a:rPr lang="en-US" dirty="0"/>
+                            <a:t>Distribution / Definition</a:t>
+                          </a:r>
+                        </a:p>
+                      </a:txBody>
+                      <a:tcPr/>
+                    </a:tc>
+                    <a:extLst>
+                      <a:ext uri="{0D108BD9-81ED-4DB2-BD59-A6C34878D82A}">
+                        <a16:rowId xmlns:a16="http://schemas.microsoft.com/office/drawing/2014/main" val="4222401980"/>
+                      </a:ext>
+                    </a:extLst>
+                  </a:tr>
+                  <a:tr h="488723">
+                    <a:tc>
+                      <a:txBody>
+                        <a:bodyPr/>
+                        <a:lstStyle/>
+                        <a:p>
+                          <a:r>
+                            <a:rPr lang="en-US" dirty="0"/>
+                            <a:t>Population size</a:t>
+                          </a:r>
+                        </a:p>
+                      </a:txBody>
+                      <a:tcPr/>
+                    </a:tc>
+                    <a:tc>
+                      <a:txBody>
+                        <a:bodyPr/>
+                        <a:lstStyle/>
+                        <a:p>
+                          <a:pPr algn="ctr"/>
+                          <a:r>
+                            <a:rPr lang="en-US" dirty="0"/>
+                            <a:t>m (fixed)</a:t>
+                          </a:r>
+                        </a:p>
+                      </a:txBody>
+                      <a:tcPr/>
+                    </a:tc>
+                    <a:extLst>
+                      <a:ext uri="{0D108BD9-81ED-4DB2-BD59-A6C34878D82A}">
+                        <a16:rowId xmlns:a16="http://schemas.microsoft.com/office/drawing/2014/main" val="2934207172"/>
+                      </a:ext>
+                    </a:extLst>
+                  </a:tr>
+                  <a:tr h="488723">
+                    <a:tc>
+                      <a:txBody>
+                        <a:bodyPr/>
+                        <a:lstStyle/>
+                        <a:p>
+                          <a:r>
+                            <a:rPr lang="en-US" dirty="0"/>
+                            <a:t>Treatment Assignment</a:t>
+                          </a:r>
+                        </a:p>
+                      </a:txBody>
+                      <a:tcPr/>
+                    </a:tc>
+                    <a:tc>
+                      <a:txBody>
+                        <a:bodyPr/>
+                        <a:lstStyle/>
+                        <a:p>
+                          <a:endParaRPr lang="en-US"/>
+                        </a:p>
+                      </a:txBody>
+                      <a:tcPr>
+                        <a:blipFill>
+                          <a:blip r:embed="rId2"/>
+                          <a:stretch>
+                            <a:fillRect l="-100239" t="-202564" r="-477" b="-271795"/>
+                          </a:stretch>
+                        </a:blipFill>
+                      </a:tcPr>
+                    </a:tc>
+                    <a:extLst>
+                      <a:ext uri="{0D108BD9-81ED-4DB2-BD59-A6C34878D82A}">
+                        <a16:rowId xmlns:a16="http://schemas.microsoft.com/office/drawing/2014/main" val="1723975838"/>
+                      </a:ext>
+                    </a:extLst>
+                  </a:tr>
+                  <a:tr h="838780">
+                    <a:tc>
+                      <a:txBody>
+                        <a:bodyPr/>
+                        <a:lstStyle/>
+                        <a:p>
+                          <a:r>
+                            <a:rPr lang="en-US" dirty="0"/>
+                            <a:t>Potential Outcomes</a:t>
+                          </a:r>
+                        </a:p>
+                      </a:txBody>
+                      <a:tcPr/>
+                    </a:tc>
+                    <a:tc>
+                      <a:txBody>
+                        <a:bodyPr/>
+                        <a:lstStyle/>
+                        <a:p>
+                          <a:endParaRPr lang="en-US"/>
+                        </a:p>
+                      </a:txBody>
+                      <a:tcPr>
+                        <a:blipFill>
+                          <a:blip r:embed="rId2"/>
+                          <a:stretch>
+                            <a:fillRect l="-100239" t="-178788" r="-477" b="-60606"/>
+                          </a:stretch>
+                        </a:blipFill>
+                      </a:tcPr>
+                    </a:tc>
+                    <a:extLst>
+                      <a:ext uri="{0D108BD9-81ED-4DB2-BD59-A6C34878D82A}">
+                        <a16:rowId xmlns:a16="http://schemas.microsoft.com/office/drawing/2014/main" val="757081235"/>
+                      </a:ext>
+                    </a:extLst>
+                  </a:tr>
+                  <a:tr h="488723">
+                    <a:tc>
+                      <a:txBody>
+                        <a:bodyPr/>
+                        <a:lstStyle/>
+                        <a:p>
+                          <a:r>
+                            <a:rPr lang="en-US" dirty="0"/>
+                            <a:t>Observed Outcome</a:t>
+                          </a:r>
+                        </a:p>
+                      </a:txBody>
+                      <a:tcPr/>
+                    </a:tc>
+                    <a:tc>
+                      <a:txBody>
+                        <a:bodyPr/>
+                        <a:lstStyle/>
+                        <a:p>
+                          <a:endParaRPr lang="en-US"/>
+                        </a:p>
+                      </a:txBody>
+                      <a:tcPr>
+                        <a:blipFill>
+                          <a:blip r:embed="rId2"/>
+                          <a:stretch>
+                            <a:fillRect l="-100239" t="-471795" r="-477" b="-2564"/>
+                          </a:stretch>
+                        </a:blipFill>
+                      </a:tcPr>
+                    </a:tc>
+                    <a:extLst>
+                      <a:ext uri="{0D108BD9-81ED-4DB2-BD59-A6C34878D82A}">
+                        <a16:rowId xmlns:a16="http://schemas.microsoft.com/office/drawing/2014/main" val="3172079154"/>
+                      </a:ext>
+                    </a:extLst>
+                  </a:tr>
+                </a:tbl>
+              </a:graphicData>
+            </a:graphic>
+          </p:graphicFrame>
+        </mc:Fallback>
+      </mc:AlternateContent>
+      <p:sp>
+        <p:nvSpPr>
+          <p:cNvPr id="5" name="Slide Number Placeholder 4">
+            <a:extLst>
+              <a:ext uri="{FF2B5EF4-FFF2-40B4-BE49-F238E27FC236}">
+                <a16:creationId xmlns:a16="http://schemas.microsoft.com/office/drawing/2014/main" id="{5170B309-5AF5-DFE6-8D4D-5091FE9C556D}"/>
+              </a:ext>
+            </a:extLst>
+          </p:cNvPr>
+          <p:cNvSpPr>
+            <a:spLocks noGrp="1"/>
+          </p:cNvSpPr>
+          <p:nvPr>
+            <p:ph type="sldNum" sz="quarter" idx="12"/>
+          </p:nvPr>
+        </p:nvSpPr>
+        <p:spPr/>
+        <p:txBody>
+          <a:bodyPr/>
+          <a:lstStyle/>
+          <a:p>
+            <a:fld id="{B9021C99-F081-FD4B-9146-F8976D51EC28}" type="slidenum">
+              <a:rPr lang="en-US" smtClean="0"/>
+              <a:t>14</a:t>
+            </a:fld>
+            <a:endParaRPr lang="en-US"/>
+          </a:p>
+        </p:txBody>
+      </p:sp>
+    </p:spTree>
+    <p:extLst>
+      <p:ext uri="{BB962C8B-B14F-4D97-AF65-F5344CB8AC3E}">
+        <p14:creationId xmlns:p14="http://schemas.microsoft.com/office/powerpoint/2010/main" val="66083419"/>
+      </p:ext>
+    </p:extLst>
+  </p:cSld>
+  <p:clrMapOvr>
+    <a:masterClrMapping/>
+  </p:clrMapOvr>
+</p:sld>
+</file>
+
+<file path=ppt/slides/slide15.xml><?xml version="1.0" encoding="utf-8"?>
+<p:sld xmlns:a="http://schemas.openxmlformats.org/drawingml/2006/main" xmlns:r="http://schemas.openxmlformats.org/officeDocument/2006/relationships" xmlns:p="http://schemas.openxmlformats.org/presentationml/2006/main">
+  <p:cSld>
+    <p:spTree>
+      <p:nvGrpSpPr>
+        <p:cNvPr id="1" name=""/>
+        <p:cNvGrpSpPr/>
+        <p:nvPr/>
+      </p:nvGrpSpPr>
+      <p:grpSpPr>
+        <a:xfrm>
+          <a:off x="0" y="0"/>
+          <a:ext cx="0" cy="0"/>
+          <a:chOff x="0" y="0"/>
+          <a:chExt cx="0" cy="0"/>
+        </a:xfrm>
+      </p:grpSpPr>
+      <p:sp>
+        <p:nvSpPr>
+          <p:cNvPr id="2" name="Title 1">
+            <a:extLst>
+              <a:ext uri="{FF2B5EF4-FFF2-40B4-BE49-F238E27FC236}">
+                <a16:creationId xmlns:a16="http://schemas.microsoft.com/office/drawing/2014/main" id="{7711AC8F-39EF-9E2A-FCF3-007AA722CC6E}"/>
+              </a:ext>
+            </a:extLst>
+          </p:cNvPr>
+          <p:cNvSpPr>
+            <a:spLocks noGrp="1"/>
+          </p:cNvSpPr>
+          <p:nvPr>
+            <p:ph type="title"/>
+          </p:nvPr>
+        </p:nvSpPr>
+        <p:spPr/>
+        <p:txBody>
+          <a:bodyPr/>
+          <a:lstStyle/>
+          <a:p>
+            <a:r>
+              <a:rPr lang="en-US" dirty="0"/>
+              <a:t>Confidence Bands</a:t>
+            </a:r>
+          </a:p>
+        </p:txBody>
+      </p:sp>
+      <p:pic>
+        <p:nvPicPr>
+          <p:cNvPr id="7" name="Content Placeholder 6" descr="A graph of a function&#10;&#10;AI-generated content may be incorrect.">
+            <a:extLst>
+              <a:ext uri="{FF2B5EF4-FFF2-40B4-BE49-F238E27FC236}">
+                <a16:creationId xmlns:a16="http://schemas.microsoft.com/office/drawing/2014/main" id="{F13D0221-329B-3B3B-BDC7-1AF1905A8D7F}"/>
+              </a:ext>
+            </a:extLst>
+          </p:cNvPr>
+          <p:cNvPicPr>
+            <a:picLocks noGrp="1" noChangeAspect="1"/>
+          </p:cNvPicPr>
+          <p:nvPr>
+            <p:ph idx="1"/>
+          </p:nvPr>
+        </p:nvPicPr>
+        <p:blipFill>
+          <a:blip r:embed="rId2"/>
+          <a:stretch>
+            <a:fillRect/>
+          </a:stretch>
+        </p:blipFill>
+        <p:spPr>
+          <a:xfrm>
+            <a:off x="8175733" y="1905000"/>
+            <a:ext cx="3742998" cy="3742998"/>
+          </a:xfrm>
+        </p:spPr>
+      </p:pic>
+      <p:sp>
+        <p:nvSpPr>
+          <p:cNvPr id="5" name="Slide Number Placeholder 4">
+            <a:extLst>
+              <a:ext uri="{FF2B5EF4-FFF2-40B4-BE49-F238E27FC236}">
+                <a16:creationId xmlns:a16="http://schemas.microsoft.com/office/drawing/2014/main" id="{E8FF79F6-AF11-7928-A6D9-3AF441DFD1CF}"/>
+              </a:ext>
+            </a:extLst>
+          </p:cNvPr>
+          <p:cNvSpPr>
+            <a:spLocks noGrp="1"/>
+          </p:cNvSpPr>
+          <p:nvPr>
+            <p:ph type="sldNum" sz="quarter" idx="12"/>
+          </p:nvPr>
+        </p:nvSpPr>
+        <p:spPr/>
+        <p:txBody>
+          <a:bodyPr/>
+          <a:lstStyle/>
+          <a:p>
+            <a:fld id="{B9021C99-F081-FD4B-9146-F8976D51EC28}" type="slidenum">
+              <a:rPr lang="en-US" smtClean="0"/>
+              <a:t>15</a:t>
+            </a:fld>
+            <a:endParaRPr lang="en-US"/>
+          </a:p>
+        </p:txBody>
+      </p:sp>
+      <p:pic>
+        <p:nvPicPr>
+          <p:cNvPr id="9" name="Picture 8" descr="A graph of a number of individuals&#10;&#10;AI-generated content may be incorrect.">
+            <a:extLst>
+              <a:ext uri="{FF2B5EF4-FFF2-40B4-BE49-F238E27FC236}">
+                <a16:creationId xmlns:a16="http://schemas.microsoft.com/office/drawing/2014/main" id="{9FD4D8CE-DE32-E3DA-8A1F-2143FECE41D9}"/>
+              </a:ext>
+            </a:extLst>
+          </p:cNvPr>
+          <p:cNvPicPr>
+            <a:picLocks noChangeAspect="1"/>
+          </p:cNvPicPr>
+          <p:nvPr/>
+        </p:nvPicPr>
+        <p:blipFill>
+          <a:blip r:embed="rId3"/>
+          <a:stretch>
+            <a:fillRect/>
+          </a:stretch>
+        </p:blipFill>
+        <p:spPr>
+          <a:xfrm>
+            <a:off x="4571999" y="1904999"/>
+            <a:ext cx="3742997" cy="3742997"/>
+          </a:xfrm>
+          <a:prstGeom prst="rect">
+            <a:avLst/>
+          </a:prstGeom>
+        </p:spPr>
+      </p:pic>
+      <p:pic>
+        <p:nvPicPr>
+          <p:cNvPr id="11" name="Picture 10" descr="A graph of a number of individuals&#10;&#10;AI-generated content may be incorrect.">
+            <a:extLst>
+              <a:ext uri="{FF2B5EF4-FFF2-40B4-BE49-F238E27FC236}">
+                <a16:creationId xmlns:a16="http://schemas.microsoft.com/office/drawing/2014/main" id="{23E48D54-42A0-2150-7CC0-39D77876A349}"/>
+              </a:ext>
+            </a:extLst>
+          </p:cNvPr>
+          <p:cNvPicPr>
+            <a:picLocks noChangeAspect="1"/>
+          </p:cNvPicPr>
+          <p:nvPr/>
+        </p:nvPicPr>
+        <p:blipFill>
+          <a:blip r:embed="rId4"/>
+          <a:stretch>
+            <a:fillRect/>
+          </a:stretch>
+        </p:blipFill>
+        <p:spPr>
+          <a:xfrm>
+            <a:off x="838200" y="1905000"/>
+            <a:ext cx="3859924" cy="3859924"/>
+          </a:xfrm>
+          <a:prstGeom prst="rect">
+            <a:avLst/>
+          </a:prstGeom>
+        </p:spPr>
+      </p:pic>
+    </p:spTree>
+    <p:extLst>
+      <p:ext uri="{BB962C8B-B14F-4D97-AF65-F5344CB8AC3E}">
+        <p14:creationId xmlns:p14="http://schemas.microsoft.com/office/powerpoint/2010/main" val="2654469095"/>
+      </p:ext>
+    </p:extLst>
+  </p:cSld>
+  <p:clrMapOvr>
+    <a:masterClrMapping/>
+  </p:clrMapOvr>
+</p:sld>
+</file>
+
+<file path=ppt/slides/slide16.xml><?xml version="1.0" encoding="utf-8"?>
+<p:sld xmlns:a="http://schemas.openxmlformats.org/drawingml/2006/main" xmlns:r="http://schemas.openxmlformats.org/officeDocument/2006/relationships" xmlns:p="http://schemas.openxmlformats.org/presentationml/2006/main">
+  <p:cSld>
+    <p:spTree>
+      <p:nvGrpSpPr>
+        <p:cNvPr id="1" name="">
+          <a:extLst>
+            <a:ext uri="{FF2B5EF4-FFF2-40B4-BE49-F238E27FC236}">
+              <a16:creationId xmlns:a16="http://schemas.microsoft.com/office/drawing/2014/main" id="{76A9DAEF-5E75-DBBE-4C6D-2E58D6FBC2C6}"/>
+            </a:ext>
+          </a:extLst>
+        </p:cNvPr>
+        <p:cNvGrpSpPr/>
+        <p:nvPr/>
+      </p:nvGrpSpPr>
+      <p:grpSpPr>
+        <a:xfrm>
+          <a:off x="0" y="0"/>
+          <a:ext cx="0" cy="0"/>
+          <a:chOff x="0" y="0"/>
+          <a:chExt cx="0" cy="0"/>
+        </a:xfrm>
+      </p:grpSpPr>
+      <p:sp>
+        <p:nvSpPr>
+          <p:cNvPr id="2" name="Title 1">
+            <a:extLst>
+              <a:ext uri="{FF2B5EF4-FFF2-40B4-BE49-F238E27FC236}">
+                <a16:creationId xmlns:a16="http://schemas.microsoft.com/office/drawing/2014/main" id="{440E2A95-7D2C-65E6-3818-EDD22E227F3A}"/>
+              </a:ext>
+            </a:extLst>
+          </p:cNvPr>
+          <p:cNvSpPr>
+            <a:spLocks noGrp="1"/>
+          </p:cNvSpPr>
+          <p:nvPr>
+            <p:ph type="title"/>
+          </p:nvPr>
+        </p:nvSpPr>
+        <p:spPr/>
+        <p:txBody>
+          <a:bodyPr/>
+          <a:lstStyle/>
+          <a:p>
+            <a:r>
+              <a:rPr lang="en-US" dirty="0"/>
+              <a:t>Comparing with </a:t>
+            </a:r>
+            <a:r>
+              <a:rPr lang="en-US" dirty="0" err="1"/>
+              <a:t>Randomisation</a:t>
+            </a:r>
+            <a:r>
+              <a:rPr lang="en-US"/>
+              <a:t> Inference (RI)</a:t>
+            </a:r>
+            <a:endParaRPr lang="en-US" dirty="0"/>
+          </a:p>
+        </p:txBody>
+      </p:sp>
+      <p:sp>
+        <p:nvSpPr>
+          <p:cNvPr id="3" name="Content Placeholder 2">
+            <a:extLst>
+              <a:ext uri="{FF2B5EF4-FFF2-40B4-BE49-F238E27FC236}">
+                <a16:creationId xmlns:a16="http://schemas.microsoft.com/office/drawing/2014/main" id="{1B84A46A-60A1-3E04-D117-CC238B873B6E}"/>
+              </a:ext>
+            </a:extLst>
+          </p:cNvPr>
+          <p:cNvSpPr>
+            <a:spLocks noGrp="1"/>
+          </p:cNvSpPr>
+          <p:nvPr>
+            <p:ph idx="1"/>
+          </p:nvPr>
+        </p:nvSpPr>
+        <p:spPr/>
+        <p:txBody>
+          <a:bodyPr/>
+          <a:lstStyle/>
+          <a:p>
+            <a:endParaRPr lang="en-US"/>
+          </a:p>
+        </p:txBody>
+      </p:sp>
+      <p:sp>
+        <p:nvSpPr>
+          <p:cNvPr id="4" name="Footer Placeholder 3">
+            <a:extLst>
+              <a:ext uri="{FF2B5EF4-FFF2-40B4-BE49-F238E27FC236}">
+                <a16:creationId xmlns:a16="http://schemas.microsoft.com/office/drawing/2014/main" id="{751303A3-1126-DE17-68FF-FF83691B83B5}"/>
+              </a:ext>
+            </a:extLst>
+          </p:cNvPr>
+          <p:cNvSpPr>
+            <a:spLocks noGrp="1"/>
+          </p:cNvSpPr>
+          <p:nvPr>
+            <p:ph type="ftr" sz="quarter" idx="11"/>
+          </p:nvPr>
+        </p:nvSpPr>
+        <p:spPr/>
+        <p:txBody>
+          <a:bodyPr/>
+          <a:lstStyle/>
+          <a:p>
+            <a:r>
+              <a:rPr lang="en-US"/>
+              <a:t>Myoung-jae Lee (1999). Median treatment effect in randomized trials.</a:t>
+            </a:r>
+          </a:p>
+        </p:txBody>
+      </p:sp>
+      <p:sp>
+        <p:nvSpPr>
+          <p:cNvPr id="5" name="Slide Number Placeholder 4">
+            <a:extLst>
+              <a:ext uri="{FF2B5EF4-FFF2-40B4-BE49-F238E27FC236}">
+                <a16:creationId xmlns:a16="http://schemas.microsoft.com/office/drawing/2014/main" id="{FEBD7BDF-F20D-BABD-16E1-87CFB0EEF1B4}"/>
+              </a:ext>
+            </a:extLst>
+          </p:cNvPr>
+          <p:cNvSpPr>
+            <a:spLocks noGrp="1"/>
+          </p:cNvSpPr>
+          <p:nvPr>
+            <p:ph type="sldNum" sz="quarter" idx="12"/>
+          </p:nvPr>
+        </p:nvSpPr>
+        <p:spPr/>
+        <p:txBody>
+          <a:bodyPr/>
+          <a:lstStyle/>
+          <a:p>
+            <a:fld id="{B9021C99-F081-FD4B-9146-F8976D51EC28}" type="slidenum">
+              <a:rPr lang="en-US" smtClean="0"/>
+              <a:t>16</a:t>
+            </a:fld>
+            <a:endParaRPr lang="en-US"/>
+          </a:p>
+        </p:txBody>
+      </p:sp>
+    </p:spTree>
+    <p:extLst>
+      <p:ext uri="{BB962C8B-B14F-4D97-AF65-F5344CB8AC3E}">
+        <p14:creationId xmlns:p14="http://schemas.microsoft.com/office/powerpoint/2010/main" val="2695608197"/>
+      </p:ext>
+    </p:extLst>
+  </p:cSld>
+  <p:clrMapOvr>
+    <a:masterClrMapping/>
+  </p:clrMapOvr>
+</p:sld>
+</file>
+
+<file path=ppt/slides/slide17.xml><?xml version="1.0" encoding="utf-8"?>
+<p:sld xmlns:a="http://schemas.openxmlformats.org/drawingml/2006/main" xmlns:r="http://schemas.openxmlformats.org/officeDocument/2006/relationships" xmlns:p="http://schemas.openxmlformats.org/presentationml/2006/main">
+  <p:cSld>
+    <p:spTree>
+      <p:nvGrpSpPr>
+        <p:cNvPr id="1" name=""/>
+        <p:cNvGrpSpPr/>
+        <p:nvPr/>
+      </p:nvGrpSpPr>
+      <p:grpSpPr>
+        <a:xfrm>
+          <a:off x="0" y="0"/>
+          <a:ext cx="0" cy="0"/>
+          <a:chOff x="0" y="0"/>
+          <a:chExt cx="0" cy="0"/>
+        </a:xfrm>
+      </p:grpSpPr>
+      <p:sp>
+        <p:nvSpPr>
+          <p:cNvPr id="2" name="Title 1">
+            <a:extLst>
+              <a:ext uri="{FF2B5EF4-FFF2-40B4-BE49-F238E27FC236}">
+                <a16:creationId xmlns:a16="http://schemas.microsoft.com/office/drawing/2014/main" id="{D7F83559-BEDF-C8B6-A264-82130346AA32}"/>
+              </a:ext>
+            </a:extLst>
+          </p:cNvPr>
+          <p:cNvSpPr>
+            <a:spLocks noGrp="1"/>
+          </p:cNvSpPr>
+          <p:nvPr>
+            <p:ph type="title"/>
+          </p:nvPr>
+        </p:nvSpPr>
+        <p:spPr/>
+        <p:txBody>
+          <a:bodyPr/>
+          <a:lstStyle/>
+          <a:p>
+            <a:r>
+              <a:rPr lang="en-US" dirty="0"/>
+              <a:t>Conjecture With Tight Bounds</a:t>
+            </a:r>
+          </a:p>
+        </p:txBody>
+      </p:sp>
+      <mc:AlternateContent xmlns:mc="http://schemas.openxmlformats.org/markup-compatibility/2006">
+        <mc:Choice xmlns:a14="http://schemas.microsoft.com/office/drawing/2010/main" Requires="a14">
+          <p:sp>
+            <p:nvSpPr>
+              <p:cNvPr id="3" name="Content Placeholder 2">
+                <a:extLst>
+                  <a:ext uri="{FF2B5EF4-FFF2-40B4-BE49-F238E27FC236}">
+                    <a16:creationId xmlns:a16="http://schemas.microsoft.com/office/drawing/2014/main" id="{0CC6E971-102B-A2E1-7381-5764B48B5FBB}"/>
+                  </a:ext>
+                </a:extLst>
+              </p:cNvPr>
+              <p:cNvSpPr>
+                <a:spLocks noGrp="1"/>
+              </p:cNvSpPr>
+              <p:nvPr>
+                <p:ph idx="1"/>
+              </p:nvPr>
+            </p:nvSpPr>
+            <p:spPr/>
+            <p:txBody>
+              <a:bodyPr/>
+              <a:lstStyle/>
+              <a:p>
+                <a:pPr marL="0" indent="0">
+                  <a:buNone/>
+                </a:pPr>
+                <a:r>
+                  <a:rPr lang="en-US" dirty="0"/>
+                  <a:t>For our proof technique, we get this inequality without the tightest bounds</a:t>
+                </a:r>
+              </a:p>
+              <a:p>
+                <a:pPr marL="0" indent="0" algn="ctr">
+                  <a:buNone/>
+                </a:pPr>
+                <a14:m>
+                  <m:oMathPara xmlns:m="http://schemas.openxmlformats.org/officeDocument/2006/math">
+                    <m:oMathParaPr>
+                      <m:jc m:val="centerGroup"/>
+                    </m:oMathParaPr>
+                    <m:oMath xmlns:m="http://schemas.openxmlformats.org/officeDocument/2006/math">
+                      <m:func>
+                        <m:funcPr>
+                          <m:ctrlPr>
+                            <a:rPr lang="en-US" i="1" dirty="0" smtClean="0">
+                              <a:latin typeface="Cambria Math" panose="02040503050406030204" pitchFamily="18" charset="0"/>
+                            </a:rPr>
+                          </m:ctrlPr>
+                        </m:funcPr>
+                        <m:fName>
+                          <m:r>
+                            <m:rPr>
+                              <m:sty m:val="p"/>
+                            </m:rPr>
+                            <a:rPr lang="en-US" dirty="0" err="1">
+                              <a:latin typeface="Cambria Math" panose="02040503050406030204" pitchFamily="18" charset="0"/>
+                            </a:rPr>
+                            <m:t>Pr</m:t>
+                          </m:r>
+                        </m:fName>
+                        <m:e>
+                          <m:func>
+                            <m:funcPr>
+                              <m:ctrlPr>
+                                <a:rPr lang="en-US" i="1" dirty="0">
+                                  <a:latin typeface="Cambria Math" panose="02040503050406030204" pitchFamily="18" charset="0"/>
+                                </a:rPr>
+                              </m:ctrlPr>
+                            </m:funcPr>
+                            <m:fName>
+                              <m:limLow>
+                                <m:limLowPr>
+                                  <m:ctrlPr>
+                                    <a:rPr lang="en-US" i="1" dirty="0">
+                                      <a:latin typeface="Cambria Math" panose="02040503050406030204" pitchFamily="18" charset="0"/>
+                                    </a:rPr>
+                                  </m:ctrlPr>
+                                </m:limLowPr>
+                                <m:e>
+                                  <m:r>
+                                    <m:rPr>
+                                      <m:sty m:val="p"/>
+                                    </m:rPr>
+                                    <a:rPr lang="en-US" dirty="0">
+                                      <a:latin typeface="Cambria Math" panose="02040503050406030204" pitchFamily="18" charset="0"/>
+                                    </a:rPr>
+                                    <m:t>sup</m:t>
+                                  </m:r>
+                                </m:e>
+                                <m:lim>
+                                  <m:r>
+                                    <a:rPr lang="en-US" i="1" dirty="0">
+                                      <a:latin typeface="Cambria Math" panose="02040503050406030204" pitchFamily="18" charset="0"/>
+                                    </a:rPr>
+                                    <m:t>𝑥</m:t>
+                                  </m:r>
+                                  <m:r>
+                                    <a:rPr lang="en-US" i="1" dirty="0">
+                                      <a:latin typeface="Cambria Math" panose="02040503050406030204" pitchFamily="18" charset="0"/>
+                                    </a:rPr>
+                                    <m:t>∈</m:t>
+                                  </m:r>
+                                  <m:r>
+                                    <a:rPr lang="en-US" i="1" dirty="0">
+                                      <a:latin typeface="Cambria Math" panose="02040503050406030204" pitchFamily="18" charset="0"/>
+                                    </a:rPr>
+                                    <m:t>𝑅</m:t>
+                                  </m:r>
+                                </m:lim>
+                              </m:limLow>
+                            </m:fName>
+                            <m:e>
+                              <m:d>
+                                <m:dPr>
+                                  <m:begChr m:val="|"/>
+                                  <m:endChr m:val="|"/>
+                                  <m:ctrlPr>
+                                    <a:rPr lang="en-US" i="1" dirty="0">
+                                      <a:latin typeface="Cambria Math" panose="02040503050406030204" pitchFamily="18" charset="0"/>
+                                    </a:rPr>
+                                  </m:ctrlPr>
+                                </m:dPr>
+                                <m:e>
+                                  <m:acc>
+                                    <m:accPr>
+                                      <m:chr m:val="̂"/>
+                                      <m:ctrlPr>
+                                        <a:rPr lang="en-US" i="1" dirty="0">
+                                          <a:latin typeface="Cambria Math" panose="02040503050406030204" pitchFamily="18" charset="0"/>
+                                        </a:rPr>
+                                      </m:ctrlPr>
+                                    </m:accPr>
+                                    <m:e>
+                                      <m:r>
+                                        <a:rPr lang="en-US" i="1" dirty="0">
+                                          <a:latin typeface="Cambria Math" panose="02040503050406030204" pitchFamily="18" charset="0"/>
+                                        </a:rPr>
+                                        <m:t>𝐹</m:t>
+                                      </m:r>
+                                    </m:e>
+                                  </m:acc>
+                                  <m:d>
+                                    <m:dPr>
+                                      <m:ctrlPr>
+                                        <a:rPr lang="en-US" i="1" dirty="0">
+                                          <a:latin typeface="Cambria Math" panose="02040503050406030204" pitchFamily="18" charset="0"/>
+                                        </a:rPr>
+                                      </m:ctrlPr>
+                                    </m:dPr>
+                                    <m:e>
+                                      <m:r>
+                                        <a:rPr lang="en-US" i="1" dirty="0">
+                                          <a:latin typeface="Cambria Math" panose="02040503050406030204" pitchFamily="18" charset="0"/>
+                                        </a:rPr>
+                                        <m:t>𝑥</m:t>
+                                      </m:r>
+                                    </m:e>
+                                  </m:d>
+                                  <m:r>
+                                    <a:rPr lang="en-US" i="1" dirty="0">
+                                      <a:latin typeface="Cambria Math" panose="02040503050406030204" pitchFamily="18" charset="0"/>
+                                    </a:rPr>
+                                    <m:t>−</m:t>
+                                  </m:r>
+                                  <m:r>
+                                    <a:rPr lang="en-US" i="1" dirty="0">
+                                      <a:latin typeface="Cambria Math" panose="02040503050406030204" pitchFamily="18" charset="0"/>
+                                    </a:rPr>
+                                    <m:t>𝐹</m:t>
+                                  </m:r>
+                                  <m:d>
+                                    <m:dPr>
+                                      <m:ctrlPr>
+                                        <a:rPr lang="en-US" i="1" dirty="0">
+                                          <a:latin typeface="Cambria Math" panose="02040503050406030204" pitchFamily="18" charset="0"/>
+                                        </a:rPr>
+                                      </m:ctrlPr>
+                                    </m:dPr>
+                                    <m:e>
+                                      <m:r>
+                                        <a:rPr lang="en-US" i="1" dirty="0">
+                                          <a:latin typeface="Cambria Math" panose="02040503050406030204" pitchFamily="18" charset="0"/>
+                                        </a:rPr>
+                                        <m:t>𝑥</m:t>
+                                      </m:r>
+                                    </m:e>
+                                  </m:d>
+                                </m:e>
+                              </m:d>
+                            </m:e>
+                          </m:func>
+                          <m:r>
+                            <a:rPr lang="en-US" i="1" dirty="0">
+                              <a:latin typeface="Cambria Math" panose="02040503050406030204" pitchFamily="18" charset="0"/>
+                            </a:rPr>
+                            <m:t>&gt;</m:t>
+                          </m:r>
+                          <m:r>
+                            <a:rPr lang="en-US" i="1" dirty="0">
+                              <a:latin typeface="Cambria Math" panose="02040503050406030204" pitchFamily="18" charset="0"/>
+                            </a:rPr>
+                            <m:t>𝜖</m:t>
+                          </m:r>
+                        </m:e>
+                      </m:func>
+                      <m:r>
+                        <a:rPr lang="en-US" i="1" dirty="0">
+                          <a:latin typeface="Cambria Math" panose="02040503050406030204" pitchFamily="18" charset="0"/>
+                        </a:rPr>
+                        <m:t>≤</m:t>
+                      </m:r>
+                      <m:r>
+                        <a:rPr lang="en-US" b="0" i="1" dirty="0" smtClean="0">
+                          <a:latin typeface="Cambria Math" panose="02040503050406030204" pitchFamily="18" charset="0"/>
+                        </a:rPr>
+                        <m:t>4</m:t>
+                      </m:r>
+                      <m:r>
+                        <a:rPr lang="en-US" i="1" dirty="0">
+                          <a:latin typeface="Cambria Math" panose="02040503050406030204" pitchFamily="18" charset="0"/>
+                        </a:rPr>
+                        <m:t>𝑒𝑥𝑝</m:t>
+                      </m:r>
+                      <m:d>
+                        <m:dPr>
+                          <m:ctrlPr>
+                            <a:rPr lang="en-US" b="0" i="1" dirty="0" smtClean="0">
+                              <a:latin typeface="Cambria Math" panose="02040503050406030204" pitchFamily="18" charset="0"/>
+                            </a:rPr>
+                          </m:ctrlPr>
+                        </m:dPr>
+                        <m:e>
+                          <m:r>
+                            <a:rPr lang="en-US" i="1" dirty="0">
+                              <a:latin typeface="Cambria Math" panose="02040503050406030204" pitchFamily="18" charset="0"/>
+                            </a:rPr>
+                            <m:t>−</m:t>
+                          </m:r>
+                          <m:f>
+                            <m:fPr>
+                              <m:ctrlPr>
+                                <a:rPr lang="en-US" i="1" dirty="0" smtClean="0">
+                                  <a:latin typeface="Cambria Math" panose="02040503050406030204" pitchFamily="18" charset="0"/>
+                                </a:rPr>
+                              </m:ctrlPr>
+                            </m:fPr>
+                            <m:num>
+                              <m:r>
+                                <a:rPr lang="en-US" b="0" i="1" dirty="0" smtClean="0">
+                                  <a:latin typeface="Cambria Math" panose="02040503050406030204" pitchFamily="18" charset="0"/>
+                                </a:rPr>
+                                <m:t>1</m:t>
+                              </m:r>
+                            </m:num>
+                            <m:den>
+                              <m:r>
+                                <a:rPr lang="en-US" b="0" i="1" dirty="0" smtClean="0">
+                                  <a:latin typeface="Cambria Math" panose="02040503050406030204" pitchFamily="18" charset="0"/>
+                                </a:rPr>
+                                <m:t>8</m:t>
+                              </m:r>
+                            </m:den>
+                          </m:f>
+                          <m:r>
+                            <a:rPr lang="en-US" i="1" dirty="0">
+                              <a:latin typeface="Cambria Math" panose="02040503050406030204" pitchFamily="18" charset="0"/>
+                            </a:rPr>
+                            <m:t>𝑛</m:t>
+                          </m:r>
+                          <m:sSup>
+                            <m:sSupPr>
+                              <m:ctrlPr>
+                                <a:rPr lang="en-US" i="1" dirty="0">
+                                  <a:latin typeface="Cambria Math" panose="02040503050406030204" pitchFamily="18" charset="0"/>
+                                </a:rPr>
+                              </m:ctrlPr>
+                            </m:sSupPr>
+                            <m:e>
+                              <m:r>
+                                <a:rPr lang="en-US" i="1" dirty="0">
+                                  <a:latin typeface="Cambria Math" panose="02040503050406030204" pitchFamily="18" charset="0"/>
+                                </a:rPr>
+                                <m:t>𝜖</m:t>
+                              </m:r>
+                            </m:e>
+                            <m:sup>
+                              <m:r>
+                                <a:rPr lang="en-US" i="1" dirty="0">
+                                  <a:latin typeface="Cambria Math" panose="02040503050406030204" pitchFamily="18" charset="0"/>
+                                </a:rPr>
+                                <m:t>2</m:t>
+                              </m:r>
+                            </m:sup>
+                          </m:sSup>
+                        </m:e>
+                      </m:d>
+                      <m:r>
+                        <a:rPr lang="en-US" b="0" i="1" dirty="0" smtClean="0">
+                          <a:latin typeface="Cambria Math" panose="02040503050406030204" pitchFamily="18" charset="0"/>
+                        </a:rPr>
+                        <m:t>.</m:t>
+                      </m:r>
+                    </m:oMath>
+                  </m:oMathPara>
+                </a14:m>
+                <a:endParaRPr lang="en-US" b="0" i="1" dirty="0">
+                  <a:latin typeface="Cambria Math" panose="02040503050406030204" pitchFamily="18" charset="0"/>
+                </a:endParaRPr>
+              </a:p>
+              <a:p>
+                <a:pPr marL="0" indent="0">
+                  <a:buNone/>
+                </a:pPr>
+                <a:r>
+                  <a:rPr lang="en-US" dirty="0"/>
+                  <a:t>Modern proof techniques are harder to adapt, but we conjecture we can get </a:t>
+                </a:r>
+              </a:p>
+              <a:p>
+                <a:pPr marL="0" indent="0" algn="ctr">
+                  <a:buNone/>
+                </a:pPr>
+                <a14:m>
+                  <m:oMath xmlns:m="http://schemas.openxmlformats.org/officeDocument/2006/math">
+                    <m:func>
+                      <m:funcPr>
+                        <m:ctrlPr>
+                          <a:rPr lang="en-US" i="1" dirty="0">
+                            <a:latin typeface="Cambria Math" panose="02040503050406030204" pitchFamily="18" charset="0"/>
+                          </a:rPr>
+                        </m:ctrlPr>
+                      </m:funcPr>
+                      <m:fName>
+                        <m:r>
+                          <m:rPr>
+                            <m:sty m:val="p"/>
+                          </m:rPr>
+                          <a:rPr lang="en-US" dirty="0" err="1">
+                            <a:latin typeface="Cambria Math" panose="02040503050406030204" pitchFamily="18" charset="0"/>
+                          </a:rPr>
+                          <m:t>Pr</m:t>
+                        </m:r>
+                      </m:fName>
+                      <m:e>
+                        <m:func>
+                          <m:funcPr>
+                            <m:ctrlPr>
+                              <a:rPr lang="en-US" i="1" dirty="0">
+                                <a:latin typeface="Cambria Math" panose="02040503050406030204" pitchFamily="18" charset="0"/>
+                              </a:rPr>
+                            </m:ctrlPr>
+                          </m:funcPr>
+                          <m:fName>
+                            <m:limLow>
+                              <m:limLowPr>
+                                <m:ctrlPr>
+                                  <a:rPr lang="en-US" i="1" dirty="0">
+                                    <a:latin typeface="Cambria Math" panose="02040503050406030204" pitchFamily="18" charset="0"/>
+                                  </a:rPr>
+                                </m:ctrlPr>
+                              </m:limLowPr>
+                              <m:e>
+                                <m:r>
+                                  <m:rPr>
+                                    <m:sty m:val="p"/>
+                                  </m:rPr>
+                                  <a:rPr lang="en-US" dirty="0">
+                                    <a:latin typeface="Cambria Math" panose="02040503050406030204" pitchFamily="18" charset="0"/>
+                                  </a:rPr>
+                                  <m:t>sup</m:t>
+                                </m:r>
+                              </m:e>
+                              <m:lim>
+                                <m:r>
+                                  <a:rPr lang="en-US" i="1" dirty="0">
+                                    <a:latin typeface="Cambria Math" panose="02040503050406030204" pitchFamily="18" charset="0"/>
+                                  </a:rPr>
+                                  <m:t>𝑥</m:t>
+                                </m:r>
+                                <m:r>
+                                  <a:rPr lang="en-US" i="1" dirty="0">
+                                    <a:latin typeface="Cambria Math" panose="02040503050406030204" pitchFamily="18" charset="0"/>
+                                  </a:rPr>
+                                  <m:t>∈</m:t>
+                                </m:r>
+                                <m:r>
+                                  <a:rPr lang="en-US" i="1" dirty="0">
+                                    <a:latin typeface="Cambria Math" panose="02040503050406030204" pitchFamily="18" charset="0"/>
+                                  </a:rPr>
+                                  <m:t>𝑅</m:t>
+                                </m:r>
+                              </m:lim>
+                            </m:limLow>
+                          </m:fName>
+                          <m:e>
+                            <m:d>
+                              <m:dPr>
+                                <m:begChr m:val="|"/>
+                                <m:endChr m:val="|"/>
+                                <m:ctrlPr>
+                                  <a:rPr lang="en-US" i="1" dirty="0">
+                                    <a:latin typeface="Cambria Math" panose="02040503050406030204" pitchFamily="18" charset="0"/>
+                                  </a:rPr>
+                                </m:ctrlPr>
+                              </m:dPr>
+                              <m:e>
+                                <m:acc>
+                                  <m:accPr>
+                                    <m:chr m:val="̂"/>
+                                    <m:ctrlPr>
+                                      <a:rPr lang="en-US" i="1" dirty="0">
+                                        <a:latin typeface="Cambria Math" panose="02040503050406030204" pitchFamily="18" charset="0"/>
+                                      </a:rPr>
+                                    </m:ctrlPr>
+                                  </m:accPr>
+                                  <m:e>
+                                    <m:r>
+                                      <a:rPr lang="en-US" i="1" dirty="0">
+                                        <a:latin typeface="Cambria Math" panose="02040503050406030204" pitchFamily="18" charset="0"/>
+                                      </a:rPr>
+                                      <m:t>𝐹</m:t>
+                                    </m:r>
+                                  </m:e>
+                                </m:acc>
+                                <m:d>
+                                  <m:dPr>
+                                    <m:ctrlPr>
+                                      <a:rPr lang="en-US" i="1" dirty="0">
+                                        <a:latin typeface="Cambria Math" panose="02040503050406030204" pitchFamily="18" charset="0"/>
+                                      </a:rPr>
+                                    </m:ctrlPr>
+                                  </m:dPr>
+                                  <m:e>
+                                    <m:r>
+                                      <a:rPr lang="en-US" i="1" dirty="0">
+                                        <a:latin typeface="Cambria Math" panose="02040503050406030204" pitchFamily="18" charset="0"/>
+                                      </a:rPr>
+                                      <m:t>𝑥</m:t>
+                                    </m:r>
+                                  </m:e>
+                                </m:d>
+                                <m:r>
+                                  <a:rPr lang="en-US" i="1" dirty="0">
+                                    <a:latin typeface="Cambria Math" panose="02040503050406030204" pitchFamily="18" charset="0"/>
+                                  </a:rPr>
+                                  <m:t>−</m:t>
+                                </m:r>
+                                <m:r>
+                                  <a:rPr lang="en-US" i="1" dirty="0">
+                                    <a:latin typeface="Cambria Math" panose="02040503050406030204" pitchFamily="18" charset="0"/>
+                                  </a:rPr>
+                                  <m:t>𝐹</m:t>
+                                </m:r>
+                                <m:d>
+                                  <m:dPr>
+                                    <m:ctrlPr>
+                                      <a:rPr lang="en-US" i="1" dirty="0">
+                                        <a:latin typeface="Cambria Math" panose="02040503050406030204" pitchFamily="18" charset="0"/>
+                                      </a:rPr>
+                                    </m:ctrlPr>
+                                  </m:dPr>
+                                  <m:e>
+                                    <m:r>
+                                      <a:rPr lang="en-US" i="1" dirty="0">
+                                        <a:latin typeface="Cambria Math" panose="02040503050406030204" pitchFamily="18" charset="0"/>
+                                      </a:rPr>
+                                      <m:t>𝑥</m:t>
+                                    </m:r>
+                                  </m:e>
+                                </m:d>
+                              </m:e>
+                            </m:d>
+                          </m:e>
+                        </m:func>
+                        <m:r>
+                          <a:rPr lang="en-US" i="1" dirty="0">
+                            <a:latin typeface="Cambria Math" panose="02040503050406030204" pitchFamily="18" charset="0"/>
+                          </a:rPr>
+                          <m:t>&gt;</m:t>
+                        </m:r>
+                        <m:r>
+                          <a:rPr lang="en-US" i="1" dirty="0">
+                            <a:latin typeface="Cambria Math" panose="02040503050406030204" pitchFamily="18" charset="0"/>
+                          </a:rPr>
+                          <m:t>𝜖</m:t>
+                        </m:r>
+                      </m:e>
+                    </m:func>
+                    <m:r>
+                      <a:rPr lang="en-US" i="1" dirty="0">
+                        <a:latin typeface="Cambria Math" panose="02040503050406030204" pitchFamily="18" charset="0"/>
+                      </a:rPr>
+                      <m:t>≤</m:t>
+                    </m:r>
+                    <m:r>
+                      <a:rPr lang="en-US" b="0" i="1" dirty="0" smtClean="0">
+                        <a:latin typeface="Cambria Math" panose="02040503050406030204" pitchFamily="18" charset="0"/>
+                      </a:rPr>
+                      <m:t>2</m:t>
+                    </m:r>
+                    <m:r>
+                      <a:rPr lang="en-US" i="1" dirty="0">
+                        <a:latin typeface="Cambria Math" panose="02040503050406030204" pitchFamily="18" charset="0"/>
+                      </a:rPr>
+                      <m:t>𝑒𝑥𝑝</m:t>
+                    </m:r>
+                    <m:d>
+                      <m:dPr>
+                        <m:ctrlPr>
+                          <a:rPr lang="en-US" i="1" dirty="0">
+                            <a:latin typeface="Cambria Math" panose="02040503050406030204" pitchFamily="18" charset="0"/>
+                          </a:rPr>
+                        </m:ctrlPr>
+                      </m:dPr>
+                      <m:e>
+                        <m:r>
+                          <a:rPr lang="en-US" i="1" dirty="0">
+                            <a:latin typeface="Cambria Math" panose="02040503050406030204" pitchFamily="18" charset="0"/>
+                          </a:rPr>
+                          <m:t>−</m:t>
+                        </m:r>
+                        <m:r>
+                          <a:rPr lang="en-US" b="0" i="1" dirty="0" smtClean="0">
+                            <a:latin typeface="Cambria Math" panose="02040503050406030204" pitchFamily="18" charset="0"/>
+                          </a:rPr>
+                          <m:t>2</m:t>
+                        </m:r>
+                        <m:r>
+                          <a:rPr lang="en-US" i="1" dirty="0">
+                            <a:latin typeface="Cambria Math" panose="02040503050406030204" pitchFamily="18" charset="0"/>
+                          </a:rPr>
+                          <m:t>𝑛</m:t>
+                        </m:r>
+                        <m:sSup>
+                          <m:sSupPr>
+                            <m:ctrlPr>
+                              <a:rPr lang="en-US" i="1" dirty="0">
+                                <a:latin typeface="Cambria Math" panose="02040503050406030204" pitchFamily="18" charset="0"/>
+                              </a:rPr>
+                            </m:ctrlPr>
+                          </m:sSupPr>
+                          <m:e>
+                            <m:r>
+                              <a:rPr lang="en-US" i="1" dirty="0">
+                                <a:latin typeface="Cambria Math" panose="02040503050406030204" pitchFamily="18" charset="0"/>
+                              </a:rPr>
+                              <m:t>𝜖</m:t>
+                            </m:r>
+                          </m:e>
+                          <m:sup>
+                            <m:r>
+                              <a:rPr lang="en-US" i="1" dirty="0">
+                                <a:latin typeface="Cambria Math" panose="02040503050406030204" pitchFamily="18" charset="0"/>
+                              </a:rPr>
+                              <m:t>2</m:t>
+                            </m:r>
+                          </m:sup>
+                        </m:sSup>
+                      </m:e>
+                    </m:d>
+                  </m:oMath>
+                </a14:m>
+                <a:r>
+                  <a:rPr lang="en-US" dirty="0"/>
+                  <a:t>.</a:t>
+                </a:r>
+              </a:p>
+              <a:p>
+                <a:pPr marL="0" indent="0">
+                  <a:buNone/>
+                </a:pPr>
+                <a:r>
+                  <a:rPr lang="en-US" dirty="0"/>
+                  <a:t>With this tighter bounds, we get much better performance.</a:t>
+                </a:r>
+              </a:p>
+            </p:txBody>
+          </p:sp>
+        </mc:Choice>
+        <mc:Fallback>
+          <p:sp>
+            <p:nvSpPr>
+              <p:cNvPr id="3" name="Content Placeholder 2">
+                <a:extLst>
+                  <a:ext uri="{FF2B5EF4-FFF2-40B4-BE49-F238E27FC236}">
+                    <a16:creationId xmlns:a16="http://schemas.microsoft.com/office/drawing/2014/main" id="{0CC6E971-102B-A2E1-7381-5764B48B5FBB}"/>
+                  </a:ext>
+                </a:extLst>
+              </p:cNvPr>
+              <p:cNvSpPr>
+                <a:spLocks noGrp="1" noRot="1" noChangeAspect="1" noMove="1" noResize="1" noEditPoints="1" noAdjustHandles="1" noChangeArrowheads="1" noChangeShapeType="1" noTextEdit="1"/>
+              </p:cNvSpPr>
+              <p:nvPr>
+                <p:ph idx="1"/>
+              </p:nvPr>
+            </p:nvSpPr>
+            <p:spPr>
+              <a:blipFill>
+                <a:blip r:embed="rId2"/>
+                <a:stretch>
+                  <a:fillRect l="-1206" t="-2326" r="-1448"/>
+                </a:stretch>
+              </a:blipFill>
+            </p:spPr>
+            <p:txBody>
+              <a:bodyPr/>
+              <a:lstStyle/>
+              <a:p>
+                <a:r>
+                  <a:rPr lang="en-US">
+                    <a:noFill/>
+                  </a:rPr>
+                  <a:t> </a:t>
+                </a:r>
+              </a:p>
+            </p:txBody>
+          </p:sp>
+        </mc:Fallback>
+      </mc:AlternateContent>
+      <p:sp>
+        <p:nvSpPr>
+          <p:cNvPr id="4" name="Footer Placeholder 3">
+            <a:extLst>
+              <a:ext uri="{FF2B5EF4-FFF2-40B4-BE49-F238E27FC236}">
+                <a16:creationId xmlns:a16="http://schemas.microsoft.com/office/drawing/2014/main" id="{0F4A4634-8B38-3BBB-EE25-3AB1ED1E735B}"/>
+              </a:ext>
+            </a:extLst>
+          </p:cNvPr>
+          <p:cNvSpPr>
+            <a:spLocks noGrp="1"/>
+          </p:cNvSpPr>
+          <p:nvPr>
+            <p:ph type="ftr" sz="quarter" idx="11"/>
+          </p:nvPr>
+        </p:nvSpPr>
+        <p:spPr/>
+        <p:txBody>
+          <a:bodyPr/>
+          <a:lstStyle/>
+          <a:p>
+            <a:r>
+              <a:rPr lang="en-US"/>
+              <a:t>Myoung-jae Lee (1999). Median treatment effect in randomized trials.</a:t>
+            </a:r>
+          </a:p>
+        </p:txBody>
+      </p:sp>
+      <p:sp>
+        <p:nvSpPr>
+          <p:cNvPr id="5" name="Slide Number Placeholder 4">
+            <a:extLst>
+              <a:ext uri="{FF2B5EF4-FFF2-40B4-BE49-F238E27FC236}">
+                <a16:creationId xmlns:a16="http://schemas.microsoft.com/office/drawing/2014/main" id="{4B4A599C-CE37-6BA1-1CF6-8E6FB91E90F3}"/>
+              </a:ext>
+            </a:extLst>
+          </p:cNvPr>
+          <p:cNvSpPr>
+            <a:spLocks noGrp="1"/>
+          </p:cNvSpPr>
+          <p:nvPr>
+            <p:ph type="sldNum" sz="quarter" idx="12"/>
+          </p:nvPr>
+        </p:nvSpPr>
+        <p:spPr/>
+        <p:txBody>
+          <a:bodyPr/>
+          <a:lstStyle/>
+          <a:p>
+            <a:fld id="{B9021C99-F081-FD4B-9146-F8976D51EC28}" type="slidenum">
+              <a:rPr lang="en-US" smtClean="0"/>
+              <a:t>17</a:t>
+            </a:fld>
+            <a:endParaRPr lang="en-US"/>
+          </a:p>
+        </p:txBody>
+      </p:sp>
+    </p:spTree>
+    <p:extLst>
+      <p:ext uri="{BB962C8B-B14F-4D97-AF65-F5344CB8AC3E}">
+        <p14:creationId xmlns:p14="http://schemas.microsoft.com/office/powerpoint/2010/main" val="2949026671"/>
+      </p:ext>
+    </p:extLst>
+  </p:cSld>
+  <p:clrMapOvr>
+    <a:masterClrMapping/>
+  </p:clrMapOvr>
+</p:sld>
+</file>
+
+<file path=ppt/slides/slide18.xml><?xml version="1.0" encoding="utf-8"?>
+<p:sld xmlns:a="http://schemas.openxmlformats.org/drawingml/2006/main" xmlns:r="http://schemas.openxmlformats.org/officeDocument/2006/relationships" xmlns:p="http://schemas.openxmlformats.org/presentationml/2006/main">
+  <p:cSld>
+    <p:spTree>
+      <p:nvGrpSpPr>
+        <p:cNvPr id="1" name=""/>
+        <p:cNvGrpSpPr/>
+        <p:nvPr/>
+      </p:nvGrpSpPr>
+      <p:grpSpPr>
+        <a:xfrm>
+          <a:off x="0" y="0"/>
+          <a:ext cx="0" cy="0"/>
+          <a:chOff x="0" y="0"/>
+          <a:chExt cx="0" cy="0"/>
+        </a:xfrm>
+      </p:grpSpPr>
+      <p:sp>
+        <p:nvSpPr>
+          <p:cNvPr id="2" name="Title 1">
+            <a:extLst>
+              <a:ext uri="{FF2B5EF4-FFF2-40B4-BE49-F238E27FC236}">
+                <a16:creationId xmlns:a16="http://schemas.microsoft.com/office/drawing/2014/main" id="{EE6C86FF-8F11-D3BC-24C2-1ABE71FC8E56}"/>
+              </a:ext>
+            </a:extLst>
+          </p:cNvPr>
+          <p:cNvSpPr>
+            <a:spLocks noGrp="1"/>
+          </p:cNvSpPr>
+          <p:nvPr>
+            <p:ph type="title"/>
+          </p:nvPr>
+        </p:nvSpPr>
+        <p:spPr/>
+        <p:txBody>
+          <a:bodyPr/>
+          <a:lstStyle/>
+          <a:p>
+            <a:r>
+              <a:rPr lang="en-US" dirty="0"/>
+              <a:t>Tighter Confidence Bands</a:t>
+            </a:r>
+          </a:p>
+        </p:txBody>
+      </p:sp>
+      <p:pic>
+        <p:nvPicPr>
+          <p:cNvPr id="7" name="Content Placeholder 6" descr="A graph of a graph&#10;&#10;AI-generated content may be incorrect.">
+            <a:extLst>
+              <a:ext uri="{FF2B5EF4-FFF2-40B4-BE49-F238E27FC236}">
+                <a16:creationId xmlns:a16="http://schemas.microsoft.com/office/drawing/2014/main" id="{B9E82405-0BCE-7BA4-233D-52680DCF3300}"/>
+              </a:ext>
+            </a:extLst>
+          </p:cNvPr>
+          <p:cNvPicPr>
+            <a:picLocks noGrp="1" noChangeAspect="1"/>
+          </p:cNvPicPr>
+          <p:nvPr>
+            <p:ph idx="1"/>
+          </p:nvPr>
+        </p:nvPicPr>
+        <p:blipFill>
+          <a:blip r:embed="rId2"/>
+          <a:stretch>
+            <a:fillRect/>
+          </a:stretch>
+        </p:blipFill>
+        <p:spPr>
+          <a:xfrm>
+            <a:off x="509754" y="1698570"/>
+            <a:ext cx="3528846" cy="3528846"/>
+          </a:xfrm>
+        </p:spPr>
+      </p:pic>
+      <p:sp>
+        <p:nvSpPr>
+          <p:cNvPr id="5" name="Slide Number Placeholder 4">
+            <a:extLst>
+              <a:ext uri="{FF2B5EF4-FFF2-40B4-BE49-F238E27FC236}">
+                <a16:creationId xmlns:a16="http://schemas.microsoft.com/office/drawing/2014/main" id="{8A30785E-84BE-720C-22A0-FADE809128B1}"/>
+              </a:ext>
+            </a:extLst>
+          </p:cNvPr>
+          <p:cNvSpPr>
+            <a:spLocks noGrp="1"/>
+          </p:cNvSpPr>
+          <p:nvPr>
+            <p:ph type="sldNum" sz="quarter" idx="12"/>
+          </p:nvPr>
+        </p:nvSpPr>
+        <p:spPr/>
+        <p:txBody>
+          <a:bodyPr/>
+          <a:lstStyle/>
+          <a:p>
+            <a:fld id="{B9021C99-F081-FD4B-9146-F8976D51EC28}" type="slidenum">
+              <a:rPr lang="en-US" smtClean="0"/>
+              <a:t>18</a:t>
+            </a:fld>
+            <a:endParaRPr lang="en-US"/>
+          </a:p>
+        </p:txBody>
+      </p:sp>
+      <p:pic>
+        <p:nvPicPr>
+          <p:cNvPr id="9" name="Picture 8" descr="A graph of a graph&#10;&#10;AI-generated content may be incorrect.">
+            <a:extLst>
+              <a:ext uri="{FF2B5EF4-FFF2-40B4-BE49-F238E27FC236}">
+                <a16:creationId xmlns:a16="http://schemas.microsoft.com/office/drawing/2014/main" id="{842A241E-FE87-1B9F-DCCA-16E16832C610}"/>
+              </a:ext>
+            </a:extLst>
+          </p:cNvPr>
+          <p:cNvPicPr>
+            <a:picLocks noChangeAspect="1"/>
+          </p:cNvPicPr>
+          <p:nvPr/>
+        </p:nvPicPr>
+        <p:blipFill>
+          <a:blip r:embed="rId3"/>
+          <a:stretch>
+            <a:fillRect/>
+          </a:stretch>
+        </p:blipFill>
+        <p:spPr>
+          <a:xfrm>
+            <a:off x="4539811" y="1720904"/>
+            <a:ext cx="3528846" cy="3528846"/>
+          </a:xfrm>
+          <a:prstGeom prst="rect">
+            <a:avLst/>
+          </a:prstGeom>
+        </p:spPr>
+      </p:pic>
+      <p:pic>
+        <p:nvPicPr>
+          <p:cNvPr id="11" name="Picture 10" descr="A graph of a number of individuals&#10;&#10;AI-generated content may be incorrect.">
+            <a:extLst>
+              <a:ext uri="{FF2B5EF4-FFF2-40B4-BE49-F238E27FC236}">
+                <a16:creationId xmlns:a16="http://schemas.microsoft.com/office/drawing/2014/main" id="{21C4FF91-0662-1E31-28C7-EA5EEF0C2AAA}"/>
+              </a:ext>
+            </a:extLst>
+          </p:cNvPr>
+          <p:cNvPicPr>
+            <a:picLocks noChangeAspect="1"/>
+          </p:cNvPicPr>
+          <p:nvPr/>
+        </p:nvPicPr>
+        <p:blipFill>
+          <a:blip r:embed="rId4"/>
+          <a:stretch>
+            <a:fillRect/>
+          </a:stretch>
+        </p:blipFill>
+        <p:spPr>
+          <a:xfrm>
+            <a:off x="8153400" y="1698570"/>
+            <a:ext cx="3528846" cy="3528846"/>
+          </a:xfrm>
+          <a:prstGeom prst="rect">
+            <a:avLst/>
+          </a:prstGeom>
+        </p:spPr>
+      </p:pic>
+      <p:sp>
+        <p:nvSpPr>
+          <p:cNvPr id="12" name="TextBox 11">
+            <a:extLst>
+              <a:ext uri="{FF2B5EF4-FFF2-40B4-BE49-F238E27FC236}">
+                <a16:creationId xmlns:a16="http://schemas.microsoft.com/office/drawing/2014/main" id="{597E0142-5C47-2D5A-8405-765E59156D75}"/>
+              </a:ext>
+            </a:extLst>
+          </p:cNvPr>
+          <p:cNvSpPr txBox="1"/>
+          <p:nvPr/>
+        </p:nvSpPr>
+        <p:spPr>
+          <a:xfrm>
+            <a:off x="838200" y="5249750"/>
+            <a:ext cx="9046779" cy="369332"/>
+          </a:xfrm>
+          <a:prstGeom prst="rect">
+            <a:avLst/>
+          </a:prstGeom>
+          <a:noFill/>
+        </p:spPr>
+        <p:txBody>
+          <a:bodyPr wrap="square" rtlCol="0">
+            <a:spAutoFit/>
+          </a:bodyPr>
+          <a:lstStyle/>
+          <a:p>
+            <a:r>
+              <a:rPr lang="en-US" dirty="0"/>
+              <a:t>Better widths for much less sample size m = 100, 500, and 1000.</a:t>
+            </a:r>
+          </a:p>
+        </p:txBody>
+      </p:sp>
+    </p:spTree>
+    <p:extLst>
+      <p:ext uri="{BB962C8B-B14F-4D97-AF65-F5344CB8AC3E}">
+        <p14:creationId xmlns:p14="http://schemas.microsoft.com/office/powerpoint/2010/main" val="3703705853"/>
+      </p:ext>
+    </p:extLst>
+  </p:cSld>
+  <p:clrMapOvr>
+    <a:masterClrMapping/>
+  </p:clrMapOvr>
+</p:sld>
+</file>
+
+<file path=ppt/slides/slide19.xml><?xml version="1.0" encoding="utf-8"?>
+<p:sld xmlns:a="http://schemas.openxmlformats.org/drawingml/2006/main" xmlns:r="http://schemas.openxmlformats.org/officeDocument/2006/relationships" xmlns:p="http://schemas.openxmlformats.org/presentationml/2006/main">
+  <p:cSld>
+    <p:spTree>
+      <p:nvGrpSpPr>
+        <p:cNvPr id="1" name=""/>
+        <p:cNvGrpSpPr/>
+        <p:nvPr/>
+      </p:nvGrpSpPr>
+      <p:grpSpPr>
+        <a:xfrm>
+          <a:off x="0" y="0"/>
+          <a:ext cx="0" cy="0"/>
+          <a:chOff x="0" y="0"/>
+          <a:chExt cx="0" cy="0"/>
+        </a:xfrm>
+      </p:grpSpPr>
+      <p:sp>
+        <p:nvSpPr>
+          <p:cNvPr id="2" name="Title 1">
+            <a:extLst>
+              <a:ext uri="{FF2B5EF4-FFF2-40B4-BE49-F238E27FC236}">
+                <a16:creationId xmlns:a16="http://schemas.microsoft.com/office/drawing/2014/main" id="{62D080C4-FE9A-DB17-6DE1-0D12AD0B98D4}"/>
+              </a:ext>
+            </a:extLst>
+          </p:cNvPr>
+          <p:cNvSpPr>
+            <a:spLocks noGrp="1"/>
+          </p:cNvSpPr>
+          <p:nvPr>
+            <p:ph type="title"/>
+          </p:nvPr>
+        </p:nvSpPr>
+        <p:spPr/>
+        <p:txBody>
+          <a:bodyPr/>
+          <a:lstStyle/>
+          <a:p>
+            <a:r>
+              <a:rPr lang="en-US" dirty="0"/>
+              <a:t>Comparing with RI (Tighter Bounds)</a:t>
+            </a:r>
+          </a:p>
+        </p:txBody>
+      </p:sp>
+      <p:sp>
+        <p:nvSpPr>
+          <p:cNvPr id="3" name="Content Placeholder 2">
+            <a:extLst>
+              <a:ext uri="{FF2B5EF4-FFF2-40B4-BE49-F238E27FC236}">
+                <a16:creationId xmlns:a16="http://schemas.microsoft.com/office/drawing/2014/main" id="{B414D836-A42C-EE37-9B8A-C440D3B08CA3}"/>
+              </a:ext>
+            </a:extLst>
+          </p:cNvPr>
+          <p:cNvSpPr>
+            <a:spLocks noGrp="1"/>
+          </p:cNvSpPr>
+          <p:nvPr>
+            <p:ph idx="1"/>
+          </p:nvPr>
+        </p:nvSpPr>
+        <p:spPr/>
+        <p:txBody>
+          <a:bodyPr/>
+          <a:lstStyle/>
+          <a:p>
+            <a:endParaRPr lang="en-US"/>
+          </a:p>
+        </p:txBody>
+      </p:sp>
+      <p:sp>
+        <p:nvSpPr>
+          <p:cNvPr id="4" name="Footer Placeholder 3">
+            <a:extLst>
+              <a:ext uri="{FF2B5EF4-FFF2-40B4-BE49-F238E27FC236}">
+                <a16:creationId xmlns:a16="http://schemas.microsoft.com/office/drawing/2014/main" id="{FF077462-373B-30E9-F3A8-0B90EE49423A}"/>
+              </a:ext>
+            </a:extLst>
+          </p:cNvPr>
+          <p:cNvSpPr>
+            <a:spLocks noGrp="1"/>
+          </p:cNvSpPr>
+          <p:nvPr>
+            <p:ph type="ftr" sz="quarter" idx="11"/>
+          </p:nvPr>
+        </p:nvSpPr>
+        <p:spPr/>
+        <p:txBody>
+          <a:bodyPr/>
+          <a:lstStyle/>
+          <a:p>
+            <a:r>
+              <a:rPr lang="en-US"/>
+              <a:t>Myoung-jae Lee (1999). Median treatment effect in randomized trials.</a:t>
+            </a:r>
+          </a:p>
+        </p:txBody>
+      </p:sp>
+      <p:sp>
+        <p:nvSpPr>
+          <p:cNvPr id="5" name="Slide Number Placeholder 4">
+            <a:extLst>
+              <a:ext uri="{FF2B5EF4-FFF2-40B4-BE49-F238E27FC236}">
+                <a16:creationId xmlns:a16="http://schemas.microsoft.com/office/drawing/2014/main" id="{1F3445B9-2D0E-1AD4-4FB6-DA0701D0B5EB}"/>
+              </a:ext>
+            </a:extLst>
+          </p:cNvPr>
+          <p:cNvSpPr>
+            <a:spLocks noGrp="1"/>
+          </p:cNvSpPr>
+          <p:nvPr>
+            <p:ph type="sldNum" sz="quarter" idx="12"/>
+          </p:nvPr>
+        </p:nvSpPr>
+        <p:spPr/>
+        <p:txBody>
+          <a:bodyPr/>
+          <a:lstStyle/>
+          <a:p>
+            <a:fld id="{B9021C99-F081-FD4B-9146-F8976D51EC28}" type="slidenum">
+              <a:rPr lang="en-US" smtClean="0"/>
+              <a:t>19</a:t>
+            </a:fld>
+            <a:endParaRPr lang="en-US"/>
+          </a:p>
+        </p:txBody>
+      </p:sp>
+    </p:spTree>
+    <p:extLst>
+      <p:ext uri="{BB962C8B-B14F-4D97-AF65-F5344CB8AC3E}">
+        <p14:creationId xmlns:p14="http://schemas.microsoft.com/office/powerpoint/2010/main" val="4198159789"/>
+      </p:ext>
+    </p:extLst>
+  </p:cSld>
+  <p:clrMapOvr>
+    <a:masterClrMapping/>
+  </p:clrMapOvr>
 </p:sld>
 </file>
 
@@ -6872,6 +9607,194 @@
     <p:extLst>
       <p:ext uri="{BB962C8B-B14F-4D97-AF65-F5344CB8AC3E}">
         <p14:creationId xmlns:p14="http://schemas.microsoft.com/office/powerpoint/2010/main" val="73136900"/>
+      </p:ext>
+    </p:extLst>
+  </p:cSld>
+  <p:clrMapOvr>
+    <a:masterClrMapping/>
+  </p:clrMapOvr>
+</p:sld>
+</file>
+
+<file path=ppt/slides/slide20.xml><?xml version="1.0" encoding="utf-8"?>
+<p:sld xmlns:a="http://schemas.openxmlformats.org/drawingml/2006/main" xmlns:r="http://schemas.openxmlformats.org/officeDocument/2006/relationships" xmlns:p="http://schemas.openxmlformats.org/presentationml/2006/main">
+  <p:cSld>
+    <p:spTree>
+      <p:nvGrpSpPr>
+        <p:cNvPr id="1" name=""/>
+        <p:cNvGrpSpPr/>
+        <p:nvPr/>
+      </p:nvGrpSpPr>
+      <p:grpSpPr>
+        <a:xfrm>
+          <a:off x="0" y="0"/>
+          <a:ext cx="0" cy="0"/>
+          <a:chOff x="0" y="0"/>
+          <a:chExt cx="0" cy="0"/>
+        </a:xfrm>
+      </p:grpSpPr>
+      <p:sp>
+        <p:nvSpPr>
+          <p:cNvPr id="2" name="Title 1">
+            <a:extLst>
+              <a:ext uri="{FF2B5EF4-FFF2-40B4-BE49-F238E27FC236}">
+                <a16:creationId xmlns:a16="http://schemas.microsoft.com/office/drawing/2014/main" id="{F1D10985-3873-56D6-AC64-D094C127F2A1}"/>
+              </a:ext>
+            </a:extLst>
+          </p:cNvPr>
+          <p:cNvSpPr>
+            <a:spLocks noGrp="1"/>
+          </p:cNvSpPr>
+          <p:nvPr>
+            <p:ph type="title"/>
+          </p:nvPr>
+        </p:nvSpPr>
+        <p:spPr/>
+        <p:txBody>
+          <a:bodyPr/>
+          <a:lstStyle/>
+          <a:p>
+            <a:r>
+              <a:rPr lang="en-US" dirty="0"/>
+              <a:t>Conclusion</a:t>
+            </a:r>
+          </a:p>
+        </p:txBody>
+      </p:sp>
+      <p:sp>
+        <p:nvSpPr>
+          <p:cNvPr id="3" name="Content Placeholder 2">
+            <a:extLst>
+              <a:ext uri="{FF2B5EF4-FFF2-40B4-BE49-F238E27FC236}">
+                <a16:creationId xmlns:a16="http://schemas.microsoft.com/office/drawing/2014/main" id="{40B11FB5-A3A4-75C0-BDEA-F7F15B210A2C}"/>
+              </a:ext>
+            </a:extLst>
+          </p:cNvPr>
+          <p:cNvSpPr>
+            <a:spLocks noGrp="1"/>
+          </p:cNvSpPr>
+          <p:nvPr>
+            <p:ph idx="1"/>
+          </p:nvPr>
+        </p:nvSpPr>
+        <p:spPr/>
+        <p:txBody>
+          <a:bodyPr/>
+          <a:lstStyle/>
+          <a:p>
+            <a:pPr marL="0" indent="0">
+              <a:buNone/>
+            </a:pPr>
+            <a:r>
+              <a:rPr lang="en-US" dirty="0"/>
+              <a:t>In this presentation we</a:t>
+            </a:r>
+          </a:p>
+          <a:p>
+            <a:r>
+              <a:rPr lang="en-US" dirty="0"/>
+              <a:t>Confidence regions for distribution of ITE that are</a:t>
+            </a:r>
+          </a:p>
+          <a:p>
+            <a:pPr lvl="1"/>
+            <a:r>
+              <a:rPr lang="en-US" dirty="0"/>
+              <a:t>Finite sample exact</a:t>
+            </a:r>
+          </a:p>
+          <a:p>
+            <a:pPr lvl="1"/>
+            <a:r>
+              <a:rPr lang="en-US" dirty="0"/>
+              <a:t>Closed form</a:t>
+            </a:r>
+          </a:p>
+          <a:p>
+            <a:pPr lvl="1"/>
+            <a:r>
+              <a:rPr lang="en-US" dirty="0"/>
+              <a:t>Stronger than previous efforts in randomization inference</a:t>
+            </a:r>
+          </a:p>
+          <a:p>
+            <a:r>
+              <a:rPr lang="en-US" dirty="0"/>
+              <a:t>A stronger tool for inference of ITE helps with analysis of heterogeneous treatments.</a:t>
+            </a:r>
+          </a:p>
+          <a:p>
+            <a:r>
+              <a:rPr lang="en-US" dirty="0"/>
+              <a:t>Work on strengthening the DKW bound for stronger inference.</a:t>
+            </a:r>
+          </a:p>
+          <a:p>
+            <a:endParaRPr lang="en-US" dirty="0"/>
+          </a:p>
+        </p:txBody>
+      </p:sp>
+      <p:sp>
+        <p:nvSpPr>
+          <p:cNvPr id="4" name="Footer Placeholder 3">
+            <a:extLst>
+              <a:ext uri="{FF2B5EF4-FFF2-40B4-BE49-F238E27FC236}">
+                <a16:creationId xmlns:a16="http://schemas.microsoft.com/office/drawing/2014/main" id="{130E81B8-2208-29C1-58F8-3B91D6E1F818}"/>
+              </a:ext>
+            </a:extLst>
+          </p:cNvPr>
+          <p:cNvSpPr>
+            <a:spLocks noGrp="1"/>
+          </p:cNvSpPr>
+          <p:nvPr>
+            <p:ph type="ftr" sz="quarter" idx="11"/>
+          </p:nvPr>
+        </p:nvSpPr>
+        <p:spPr/>
+        <p:txBody>
+          <a:bodyPr/>
+          <a:lstStyle/>
+          <a:p>
+            <a:r>
+              <a:rPr lang="en-US"/>
+              <a:t>Myoung-jae Lee (1999). Median treatment effect in randomized trials.</a:t>
+            </a:r>
+          </a:p>
+        </p:txBody>
+      </p:sp>
+      <p:sp>
+        <p:nvSpPr>
+          <p:cNvPr id="5" name="Slide Number Placeholder 4">
+            <a:extLst>
+              <a:ext uri="{FF2B5EF4-FFF2-40B4-BE49-F238E27FC236}">
+                <a16:creationId xmlns:a16="http://schemas.microsoft.com/office/drawing/2014/main" id="{33A09571-5E74-35F9-E57E-D3B61E573F54}"/>
+              </a:ext>
+            </a:extLst>
+          </p:cNvPr>
+          <p:cNvSpPr>
+            <a:spLocks noGrp="1"/>
+          </p:cNvSpPr>
+          <p:nvPr>
+            <p:ph type="sldNum" sz="quarter" idx="12"/>
+          </p:nvPr>
+        </p:nvSpPr>
+        <p:spPr/>
+        <p:txBody>
+          <a:bodyPr/>
+          <a:lstStyle/>
+          <a:p>
+            <a:fld id="{B9021C99-F081-FD4B-9146-F8976D51EC28}" type="slidenum">
+              <a:rPr lang="en-US" smtClean="0"/>
+              <a:t>20</a:t>
+            </a:fld>
+            <a:endParaRPr lang="en-US"/>
+          </a:p>
+        </p:txBody>
+      </p:sp>
+    </p:spTree>
+    <p:extLst>
+      <p:ext uri="{BB962C8B-B14F-4D97-AF65-F5344CB8AC3E}">
+        <p14:creationId xmlns:p14="http://schemas.microsoft.com/office/powerpoint/2010/main" val="741735840"/>
       </p:ext>
     </p:extLst>
   </p:cSld>

</xml_diff>